<commit_message>
Refina o template Cora
Capa com o key visual original em tela cheia, um só logo por slide,
kicker coral acima dos títulos e títulos alinhados à esquerda.

Co-Authored-By: Claude Fable 5.1 <noreply@anthropic.com>
Claude-Session: https://claude.ai/code/session_01PdsmYxSMPP7HSkDtR6tasn
</commit_message>
<xml_diff>
--- a/apresentacao/cora-template.pptx
+++ b/apresentacao/cora-template.pptx
@@ -130,7 +130,7 @@
   <p:extLst>
     <p:ext uri="{521415D9-36F7-43E2-AB2F-B90AF26B5E84}">
       <p14:sectionLst xmlns:p14="http://schemas.microsoft.com/office/powerpoint/2010/main">
-        <p14:section name="Template · páginas em branco" id="{82e9a94f-ae34-fd13-c0f5-758c8d86b5a3}">
+        <p14:section name="Template · páginas em branco" id="{d61279ae-1272-6469-9491-746092d77e03}">
           <p14:sldIdLst>
             <p14:sldId id="256"/>
             <p14:sldId id="257"/>
@@ -144,7 +144,7 @@
             <p14:sldId id="265"/>
           </p14:sldIdLst>
         </p14:section>
-        <p14:section name="Conteúdo da landing page" id="{aff31288-3dd3-2986-eda0-750f85cce282}">
+        <p14:section name="Conteúdo da landing page" id="{cfa6b7e7-87df-fa65-c9c1-64ed8ebf6baa}">
           <p14:sldIdLst>
             <p14:sldId id="266"/>
             <p14:sldId id="267"/>
@@ -566,7 +566,7 @@
           <a:p>
             <a:r>
               <a:rPr lang="en-US" dirty="0"/>
-              <a:t>Capa no padrão do key visual: primeira linha em ivory, segunda em coral. Troque o texto; a foto e o logo vêm do layout.</a:t>
+              <a:t>Capa com o key visual original em tela cheia. Só o crédito no canto inferior esquerdo é editável.</a:t>
             </a:r>
             <a:endParaRPr lang="en-US" dirty="0"/>
           </a:p>
@@ -2668,7 +2668,7 @@
     <p:bg>
       <p:bgPr>
         <a:blipFill dpi="0" rotWithShape="1">
-          <a:blip r:embed="rId3">
+          <a:blip r:embed="rId2">
             <a:lum/>
           </a:blip>
           <a:srcRect/>
@@ -2817,39 +2817,15 @@
           </a:p>
         </p:txBody>
       </p:sp>
-      <p:pic>
-        <p:nvPicPr>
-          <p:cNvPr id="5" name="Image 1" descr="/tmp/claude-0/-home-user-espm/4ada8e6d-90e3-5cae-a464-bc23024773ff/scratchpad/deck/cora-color.png">    </p:cNvPr>
-          <p:cNvPicPr>
-            <a:picLocks noChangeAspect="1"/>
-          </p:cNvPicPr>
-          <p:nvPr/>
-        </p:nvPicPr>
-        <p:blipFill>
-          <a:blip r:embed="rId2"/>
-          <a:stretch>
-            <a:fillRect/>
-          </a:stretch>
-        </p:blipFill>
-        <p:spPr>
-          <a:xfrm>
-            <a:off x="548640" y="4690872"/>
-            <a:ext cx="914400" cy="235001"/>
-          </a:xfrm>
-          <a:prstGeom prst="rect">
-            <a:avLst/>
-          </a:prstGeom>
-        </p:spPr>
-      </p:pic>
-      <p:sp>
-        <p:nvSpPr>
-          <p:cNvPr id="6" name="Text 0"/>
+      <p:sp>
+        <p:nvSpPr>
+          <p:cNvPr id="5" name="Text 0"/>
           <p:cNvSpPr/>
           <p:nvPr/>
         </p:nvSpPr>
         <p:spPr>
           <a:xfrm>
-            <a:off x="1645920" y="4681728"/>
+            <a:off x="548640" y="4681728"/>
             <a:ext cx="5029200" cy="274320"/>
           </a:xfrm>
           <a:prstGeom prst="rect">
@@ -2891,7 +2867,7 @@
     <p:bg>
       <p:bgPr>
         <a:blipFill dpi="0" rotWithShape="1">
-          <a:blip r:embed="rId3">
+          <a:blip r:embed="rId1">
             <a:lum/>
           </a:blip>
           <a:srcRect/>
@@ -2916,66 +2892,18 @@
           <a:chExt cx="0" cy="0"/>
         </a:xfrm>
       </p:grpSpPr>
-      <p:pic>
-        <p:nvPicPr>
-          <p:cNvPr id="2" name="Image 0" descr="/tmp/claude-0/-home-user-espm/4ada8e6d-90e3-5cae-a464-bc23024773ff/scratchpad/deck/kv-cover.jpg">    </p:cNvPr>
-          <p:cNvPicPr>
-            <a:picLocks noChangeAspect="1"/>
-          </p:cNvPicPr>
-          <p:nvPr/>
-        </p:nvPicPr>
-        <p:blipFill>
-          <a:blip r:embed="rId1"/>
-          <a:stretch>
-            <a:fillRect/>
-          </a:stretch>
-        </p:blipFill>
-        <p:spPr>
-          <a:xfrm>
-            <a:off x="4114800" y="0"/>
-            <a:ext cx="5029200" cy="5143500"/>
-          </a:xfrm>
-          <a:prstGeom prst="rect">
-            <a:avLst/>
-          </a:prstGeom>
-        </p:spPr>
-      </p:pic>
-      <p:pic>
-        <p:nvPicPr>
-          <p:cNvPr id="3" name="Image 1" descr="/tmp/claude-0/-home-user-espm/4ada8e6d-90e3-5cae-a464-bc23024773ff/scratchpad/deck/cora-color.png">    </p:cNvPr>
-          <p:cNvPicPr>
-            <a:picLocks noChangeAspect="1"/>
-          </p:cNvPicPr>
-          <p:nvPr/>
-        </p:nvPicPr>
-        <p:blipFill>
-          <a:blip r:embed="rId2"/>
-          <a:stretch>
-            <a:fillRect/>
-          </a:stretch>
-        </p:blipFill>
-        <p:spPr>
-          <a:xfrm>
-            <a:off x="548640" y="566928"/>
-            <a:ext cx="1600200" cy="411480"/>
-          </a:xfrm>
-          <a:prstGeom prst="rect">
-            <a:avLst/>
-          </a:prstGeom>
-        </p:spPr>
-      </p:pic>
-      <p:sp>
-        <p:nvSpPr>
-          <p:cNvPr id="4" name="Text 0"/>
+      <p:sp>
+        <p:nvSpPr>
+          <p:cNvPr id="2" name="Text 0"/>
           <p:cNvSpPr/>
           <p:nvPr>
-            <p:ph idx="102" type="title" hasCustomPrompt="1"/>
-          </p:nvPr>
-        </p:nvSpPr>
-        <p:spPr>
-          <a:xfrm>
-            <a:off x="548640" y="1463040"/>
-            <a:ext cx="3383280" cy="1828800"/>
+            <p:ph idx="100" type="body" hasCustomPrompt="1"/>
+          </p:nvPr>
+        </p:nvSpPr>
+        <p:spPr>
+          <a:xfrm>
+            <a:off x="566928" y="4069080"/>
+            <a:ext cx="3291840" cy="457200"/>
           </a:xfrm>
           <a:prstGeom prst="rect">
             <a:avLst/>
@@ -2987,11 +2915,8 @@
           <a:bodyPr wrap="square" rtlCol="0"/>
           <a:lstStyle>
             <a:lvl1pPr algn="l" indent="0" marL="0">
-              <a:lnSpc>
-                <a:spcPct val="95000"/>
-              </a:lnSpc>
-              <a:buNone/>
-              <a:defRPr lang="en-US" sz="4000" dirty="0">
+              <a:buNone/>
+              <a:defRPr lang="en-US" sz="1200" dirty="0">
                 <a:solidFill>
                   <a:srgbClr val="FBF6F1"/>
                 </a:solidFill>
@@ -3000,103 +2925,17 @@
           </a:lstStyle>
           <a:p>
             <a:pPr algn="l" indent="0" marL="0">
-              <a:lnSpc>
-                <a:spcPct val="95000"/>
-              </a:lnSpc>
-              <a:buNone/>
-            </a:pPr>
-            <a:r>
-              <a:rPr lang="en-US" sz="4000" dirty="0">
+              <a:buNone/>
+            </a:pPr>
+            <a:r>
+              <a:rPr lang="en-US" sz="1200" dirty="0">
                 <a:solidFill>
                   <a:srgbClr val="FBF6F1"/>
                 </a:solidFill>
               </a:rPr>
-              <a:t>Título da apresentação</a:t>
-            </a:r>
-            <a:endParaRPr lang="en-US" sz="4000" dirty="0"/>
-          </a:p>
-        </p:txBody>
-      </p:sp>
-      <p:sp>
-        <p:nvSpPr>
-          <p:cNvPr id="5" name="Text 0"/>
-          <p:cNvSpPr/>
-          <p:nvPr>
-            <p:ph idx="103" type="body" hasCustomPrompt="1"/>
-          </p:nvPr>
-        </p:nvSpPr>
-        <p:spPr>
-          <a:xfrm>
-            <a:off x="548640" y="3383280"/>
-            <a:ext cx="3291840" cy="731520"/>
-          </a:xfrm>
-          <a:prstGeom prst="rect">
-            <a:avLst/>
-          </a:prstGeom>
-          <a:noFill/>
-          <a:ln/>
-        </p:spPr>
-        <p:txBody>
-          <a:bodyPr wrap="square" rtlCol="0"/>
-          <a:lstStyle>
-            <a:lvl1pPr indent="0" marL="0">
-              <a:buNone/>
-              <a:defRPr lang="en-US" sz="1400" dirty="0">
-                <a:solidFill>
-                  <a:srgbClr val="C9B8B0"/>
-                </a:solidFill>
-              </a:defRPr>
-            </a:lvl1pPr>
-          </a:lstStyle>
-          <a:p>
-            <a:pPr indent="0" marL="0">
-              <a:buNone/>
-            </a:pPr>
-            <a:r>
-              <a:rPr lang="en-US" sz="1400" dirty="0">
-                <a:solidFill>
-                  <a:srgbClr val="C9B8B0"/>
-                </a:solidFill>
-              </a:rPr>
-              <a:t>Subtítulo · equipe · data</a:t>
-            </a:r>
-            <a:endParaRPr lang="en-US" sz="1400" dirty="0"/>
-          </a:p>
-        </p:txBody>
-      </p:sp>
-      <p:sp>
-        <p:nvSpPr>
-          <p:cNvPr id="6" name="Text 0"/>
-          <p:cNvSpPr/>
-          <p:nvPr/>
-        </p:nvSpPr>
-        <p:spPr>
-          <a:xfrm>
-            <a:off x="548640" y="4681728"/>
-            <a:ext cx="3474720" cy="274320"/>
-          </a:xfrm>
-          <a:prstGeom prst="rect">
-            <a:avLst/>
-          </a:prstGeom>
-          <a:noFill/>
-          <a:ln/>
-        </p:spPr>
-        <p:txBody>
-          <a:bodyPr wrap="square" lIns="0" tIns="0" rIns="0" bIns="0" rtlCol="0" anchor="ctr"/>
-          <a:lstStyle/>
-          <a:p>
-            <a:pPr indent="0" marL="0">
-              <a:buNone/>
-            </a:pPr>
-            <a:r>
-              <a:rPr lang="en-US" sz="900" dirty="0">
-                <a:solidFill>
-                  <a:srgbClr val="C9B8B0"/>
-                </a:solidFill>
-              </a:rPr>
-              <a:t>Projeto acadêmico ESPM · Gestão de Produtos</a:t>
-            </a:r>
-            <a:endParaRPr lang="en-US" sz="900" dirty="0"/>
+              <a:t>Equipe · disciplina · data</a:t>
+            </a:r>
+            <a:endParaRPr lang="en-US" sz="1200" dirty="0"/>
           </a:p>
         </p:txBody>
       </p:sp>
@@ -3429,13 +3268,13 @@
           <p:cNvPr id="2" name="Text 0"/>
           <p:cNvSpPr/>
           <p:nvPr>
-            <p:ph idx="100" type="title" hasCustomPrompt="1"/>
-          </p:nvPr>
-        </p:nvSpPr>
-        <p:spPr>
-          <a:xfrm>
-            <a:off x="548640" y="411480"/>
-            <a:ext cx="8046720" cy="868680"/>
+            <p:ph idx="100" type="body" hasCustomPrompt="1"/>
+          </p:nvPr>
+        </p:nvSpPr>
+        <p:spPr>
+          <a:xfrm>
+            <a:off x="548640" y="365760"/>
+            <a:ext cx="8046720" cy="256032"/>
           </a:xfrm>
           <a:prstGeom prst="rect">
             <a:avLst/>
@@ -3448,9 +3287,9 @@
           <a:lstStyle>
             <a:lvl1pPr indent="0" marL="0">
               <a:buNone/>
-              <a:defRPr lang="en-US" sz="3000" dirty="0">
-                <a:solidFill>
-                  <a:srgbClr val="2A1B18"/>
+              <a:defRPr lang="en-US" sz="900" b="1" spc="200" kern="0" dirty="0">
+                <a:solidFill>
+                  <a:srgbClr val="FC6B59"/>
                 </a:solidFill>
               </a:defRPr>
             </a:lvl1pPr>
@@ -3460,14 +3299,14 @@
               <a:buNone/>
             </a:pPr>
             <a:r>
-              <a:rPr lang="en-US" sz="3000" dirty="0">
-                <a:solidFill>
-                  <a:srgbClr val="2A1B18"/>
-                </a:solidFill>
-              </a:rPr>
-              <a:t>Título do slide</a:t>
-            </a:r>
-            <a:endParaRPr lang="en-US" sz="3000" dirty="0"/>
+              <a:rPr lang="en-US" sz="900" b="1" spc="200" kern="0" dirty="0">
+                <a:solidFill>
+                  <a:srgbClr val="FC6B59"/>
+                </a:solidFill>
+              </a:rPr>
+              <a:t>KICKER DA SEÇÃO</a:t>
+            </a:r>
+            <a:endParaRPr lang="en-US" sz="900" dirty="0"/>
           </a:p>
         </p:txBody>
       </p:sp>
@@ -3476,7 +3315,54 @@
           <p:cNvPr id="3" name="Text 0"/>
           <p:cNvSpPr/>
           <p:nvPr>
-            <p:ph idx="101" type="body" hasCustomPrompt="1"/>
+            <p:ph idx="101" type="title" hasCustomPrompt="1"/>
+          </p:nvPr>
+        </p:nvSpPr>
+        <p:spPr>
+          <a:xfrm>
+            <a:off x="548640" y="621792"/>
+            <a:ext cx="8046720" cy="731520"/>
+          </a:xfrm>
+          <a:prstGeom prst="rect">
+            <a:avLst/>
+          </a:prstGeom>
+          <a:noFill/>
+          <a:ln/>
+        </p:spPr>
+        <p:txBody>
+          <a:bodyPr wrap="square" rtlCol="0"/>
+          <a:lstStyle>
+            <a:lvl1pPr algn="l" indent="0" marL="0">
+              <a:buNone/>
+              <a:defRPr lang="en-US" sz="2800" dirty="0">
+                <a:solidFill>
+                  <a:srgbClr val="2A1B18"/>
+                </a:solidFill>
+              </a:defRPr>
+            </a:lvl1pPr>
+          </a:lstStyle>
+          <a:p>
+            <a:pPr algn="l" indent="0" marL="0">
+              <a:buNone/>
+            </a:pPr>
+            <a:r>
+              <a:rPr lang="en-US" sz="2800" dirty="0">
+                <a:solidFill>
+                  <a:srgbClr val="2A1B18"/>
+                </a:solidFill>
+              </a:rPr>
+              <a:t>Título do slide</a:t>
+            </a:r>
+            <a:endParaRPr lang="en-US" sz="2800" dirty="0"/>
+          </a:p>
+        </p:txBody>
+      </p:sp>
+      <p:sp>
+        <p:nvSpPr>
+          <p:cNvPr id="4" name="Text 0"/>
+          <p:cNvSpPr/>
+          <p:nvPr>
+            <p:ph idx="102" type="body" hasCustomPrompt="1"/>
           </p:nvPr>
         </p:nvSpPr>
         <p:spPr>
@@ -3526,7 +3412,7 @@
       </p:sp>
       <p:pic>
         <p:nvPicPr>
-          <p:cNvPr id="4" name="Image 0" descr="/tmp/claude-0/-home-user-espm/4ada8e6d-90e3-5cae-a464-bc23024773ff/scratchpad/deck/cora-color.png">    </p:cNvPr>
+          <p:cNvPr id="5" name="Image 0" descr="/tmp/claude-0/-home-user-espm/4ada8e6d-90e3-5cae-a464-bc23024773ff/scratchpad/deck/cora-color.png">    </p:cNvPr>
           <p:cNvPicPr>
             <a:picLocks noChangeAspect="1"/>
           </p:cNvPicPr>
@@ -3550,7 +3436,7 @@
       </p:pic>
       <p:sp>
         <p:nvSpPr>
-          <p:cNvPr id="5" name="Text 0"/>
+          <p:cNvPr id="6" name="Text 0"/>
           <p:cNvSpPr/>
           <p:nvPr/>
         </p:nvSpPr>
@@ -3673,13 +3559,13 @@
           <p:cNvPr id="2" name="Text 0"/>
           <p:cNvSpPr/>
           <p:nvPr>
-            <p:ph idx="100" type="title" hasCustomPrompt="1"/>
-          </p:nvPr>
-        </p:nvSpPr>
-        <p:spPr>
-          <a:xfrm>
-            <a:off x="548640" y="411480"/>
-            <a:ext cx="8046720" cy="868680"/>
+            <p:ph idx="100" type="body" hasCustomPrompt="1"/>
+          </p:nvPr>
+        </p:nvSpPr>
+        <p:spPr>
+          <a:xfrm>
+            <a:off x="548640" y="365760"/>
+            <a:ext cx="8046720" cy="256032"/>
           </a:xfrm>
           <a:prstGeom prst="rect">
             <a:avLst/>
@@ -3692,9 +3578,9 @@
           <a:lstStyle>
             <a:lvl1pPr indent="0" marL="0">
               <a:buNone/>
-              <a:defRPr lang="en-US" sz="3000" dirty="0">
-                <a:solidFill>
-                  <a:srgbClr val="2A1B18"/>
+              <a:defRPr lang="en-US" sz="900" b="1" spc="200" kern="0" dirty="0">
+                <a:solidFill>
+                  <a:srgbClr val="FC6B59"/>
                 </a:solidFill>
               </a:defRPr>
             </a:lvl1pPr>
@@ -3704,20 +3590,67 @@
               <a:buNone/>
             </a:pPr>
             <a:r>
-              <a:rPr lang="en-US" sz="3000" dirty="0">
+              <a:rPr lang="en-US" sz="900" b="1" spc="200" kern="0" dirty="0">
+                <a:solidFill>
+                  <a:srgbClr val="FC6B59"/>
+                </a:solidFill>
+              </a:rPr>
+              <a:t>KICKER DA SEÇÃO</a:t>
+            </a:r>
+            <a:endParaRPr lang="en-US" sz="900" dirty="0"/>
+          </a:p>
+        </p:txBody>
+      </p:sp>
+      <p:sp>
+        <p:nvSpPr>
+          <p:cNvPr id="3" name="Text 0"/>
+          <p:cNvSpPr/>
+          <p:nvPr>
+            <p:ph idx="101" type="title" hasCustomPrompt="1"/>
+          </p:nvPr>
+        </p:nvSpPr>
+        <p:spPr>
+          <a:xfrm>
+            <a:off x="548640" y="621792"/>
+            <a:ext cx="8046720" cy="731520"/>
+          </a:xfrm>
+          <a:prstGeom prst="rect">
+            <a:avLst/>
+          </a:prstGeom>
+          <a:noFill/>
+          <a:ln/>
+        </p:spPr>
+        <p:txBody>
+          <a:bodyPr wrap="square" rtlCol="0"/>
+          <a:lstStyle>
+            <a:lvl1pPr algn="l" indent="0" marL="0">
+              <a:buNone/>
+              <a:defRPr lang="en-US" sz="2800" dirty="0">
                 <a:solidFill>
                   <a:srgbClr val="2A1B18"/>
                 </a:solidFill>
+              </a:defRPr>
+            </a:lvl1pPr>
+          </a:lstStyle>
+          <a:p>
+            <a:pPr algn="l" indent="0" marL="0">
+              <a:buNone/>
+            </a:pPr>
+            <a:r>
+              <a:rPr lang="en-US" sz="2800" dirty="0">
+                <a:solidFill>
+                  <a:srgbClr val="2A1B18"/>
+                </a:solidFill>
               </a:rPr>
               <a:t>Título do slide</a:t>
             </a:r>
-            <a:endParaRPr lang="en-US" sz="3000" dirty="0"/>
+            <a:endParaRPr lang="en-US" sz="2800" dirty="0"/>
           </a:p>
         </p:txBody>
       </p:sp>
       <p:pic>
         <p:nvPicPr>
-          <p:cNvPr id="3" name="Image 0" descr="/tmp/claude-0/-home-user-espm/4ada8e6d-90e3-5cae-a464-bc23024773ff/scratchpad/deck/cora-color.png">    </p:cNvPr>
+          <p:cNvPr id="4" name="Image 0" descr="/tmp/claude-0/-home-user-espm/4ada8e6d-90e3-5cae-a464-bc23024773ff/scratchpad/deck/cora-color.png">    </p:cNvPr>
           <p:cNvPicPr>
             <a:picLocks noChangeAspect="1"/>
           </p:cNvPicPr>
@@ -3741,7 +3674,7 @@
       </p:pic>
       <p:sp>
         <p:nvSpPr>
-          <p:cNvPr id="4" name="Text 0"/>
+          <p:cNvPr id="5" name="Text 0"/>
           <p:cNvSpPr/>
           <p:nvPr/>
         </p:nvSpPr>
@@ -3864,13 +3797,13 @@
           <p:cNvPr id="2" name="Text 0"/>
           <p:cNvSpPr/>
           <p:nvPr>
-            <p:ph idx="100" type="title" hasCustomPrompt="1"/>
-          </p:nvPr>
-        </p:nvSpPr>
-        <p:spPr>
-          <a:xfrm>
-            <a:off x="548640" y="411480"/>
-            <a:ext cx="8046720" cy="868680"/>
+            <p:ph idx="100" type="body" hasCustomPrompt="1"/>
+          </p:nvPr>
+        </p:nvSpPr>
+        <p:spPr>
+          <a:xfrm>
+            <a:off x="548640" y="365760"/>
+            <a:ext cx="8046720" cy="256032"/>
           </a:xfrm>
           <a:prstGeom prst="rect">
             <a:avLst/>
@@ -3883,9 +3816,9 @@
           <a:lstStyle>
             <a:lvl1pPr indent="0" marL="0">
               <a:buNone/>
-              <a:defRPr lang="en-US" sz="3000" dirty="0">
-                <a:solidFill>
-                  <a:srgbClr val="2A1B18"/>
+              <a:defRPr lang="en-US" sz="900" b="1" spc="200" kern="0" dirty="0">
+                <a:solidFill>
+                  <a:srgbClr val="FC6B59"/>
                 </a:solidFill>
               </a:defRPr>
             </a:lvl1pPr>
@@ -3895,14 +3828,14 @@
               <a:buNone/>
             </a:pPr>
             <a:r>
-              <a:rPr lang="en-US" sz="3000" dirty="0">
-                <a:solidFill>
-                  <a:srgbClr val="2A1B18"/>
-                </a:solidFill>
-              </a:rPr>
-              <a:t>Título do slide</a:t>
-            </a:r>
-            <a:endParaRPr lang="en-US" sz="3000" dirty="0"/>
+              <a:rPr lang="en-US" sz="900" b="1" spc="200" kern="0" dirty="0">
+                <a:solidFill>
+                  <a:srgbClr val="FC6B59"/>
+                </a:solidFill>
+              </a:rPr>
+              <a:t>KICKER DA SEÇÃO</a:t>
+            </a:r>
+            <a:endParaRPr lang="en-US" sz="900" dirty="0"/>
           </a:p>
         </p:txBody>
       </p:sp>
@@ -3911,7 +3844,54 @@
           <p:cNvPr id="3" name="Text 0"/>
           <p:cNvSpPr/>
           <p:nvPr>
-            <p:ph idx="101" type="body" hasCustomPrompt="1"/>
+            <p:ph idx="101" type="title" hasCustomPrompt="1"/>
+          </p:nvPr>
+        </p:nvSpPr>
+        <p:spPr>
+          <a:xfrm>
+            <a:off x="548640" y="621792"/>
+            <a:ext cx="8046720" cy="731520"/>
+          </a:xfrm>
+          <a:prstGeom prst="rect">
+            <a:avLst/>
+          </a:prstGeom>
+          <a:noFill/>
+          <a:ln/>
+        </p:spPr>
+        <p:txBody>
+          <a:bodyPr wrap="square" rtlCol="0"/>
+          <a:lstStyle>
+            <a:lvl1pPr algn="l" indent="0" marL="0">
+              <a:buNone/>
+              <a:defRPr lang="en-US" sz="2800" dirty="0">
+                <a:solidFill>
+                  <a:srgbClr val="2A1B18"/>
+                </a:solidFill>
+              </a:defRPr>
+            </a:lvl1pPr>
+          </a:lstStyle>
+          <a:p>
+            <a:pPr algn="l" indent="0" marL="0">
+              <a:buNone/>
+            </a:pPr>
+            <a:r>
+              <a:rPr lang="en-US" sz="2800" dirty="0">
+                <a:solidFill>
+                  <a:srgbClr val="2A1B18"/>
+                </a:solidFill>
+              </a:rPr>
+              <a:t>Título do slide</a:t>
+            </a:r>
+            <a:endParaRPr lang="en-US" sz="2800" dirty="0"/>
+          </a:p>
+        </p:txBody>
+      </p:sp>
+      <p:sp>
+        <p:nvSpPr>
+          <p:cNvPr id="4" name="Text 0"/>
+          <p:cNvSpPr/>
+          <p:nvPr>
+            <p:ph idx="102" type="body" hasCustomPrompt="1"/>
           </p:nvPr>
         </p:nvSpPr>
         <p:spPr>
@@ -3961,10 +3941,10 @@
       </p:sp>
       <p:sp>
         <p:nvSpPr>
-          <p:cNvPr id="4" name="Text 0"/>
+          <p:cNvPr id="5" name="Text 0"/>
           <p:cNvSpPr/>
           <p:nvPr>
-            <p:ph idx="102" type="body" hasCustomPrompt="1"/>
+            <p:ph idx="103" type="body" hasCustomPrompt="1"/>
           </p:nvPr>
         </p:nvSpPr>
         <p:spPr>
@@ -4014,7 +3994,7 @@
       </p:sp>
       <p:pic>
         <p:nvPicPr>
-          <p:cNvPr id="5" name="Image 0" descr="/tmp/claude-0/-home-user-espm/4ada8e6d-90e3-5cae-a464-bc23024773ff/scratchpad/deck/cora-color.png">    </p:cNvPr>
+          <p:cNvPr id="6" name="Image 0" descr="/tmp/claude-0/-home-user-espm/4ada8e6d-90e3-5cae-a464-bc23024773ff/scratchpad/deck/cora-color.png">    </p:cNvPr>
           <p:cNvPicPr>
             <a:picLocks noChangeAspect="1"/>
           </p:cNvPicPr>
@@ -4038,7 +4018,7 @@
       </p:pic>
       <p:sp>
         <p:nvSpPr>
-          <p:cNvPr id="6" name="Text 0"/>
+          <p:cNvPr id="7" name="Text 0"/>
           <p:cNvSpPr/>
           <p:nvPr/>
         </p:nvSpPr>
@@ -4161,13 +4141,13 @@
           <p:cNvPr id="2" name="Text 0"/>
           <p:cNvSpPr/>
           <p:nvPr>
-            <p:ph idx="100" type="title" hasCustomPrompt="1"/>
-          </p:nvPr>
-        </p:nvSpPr>
-        <p:spPr>
-          <a:xfrm>
-            <a:off x="548640" y="411480"/>
-            <a:ext cx="8046720" cy="868680"/>
+            <p:ph idx="100" type="body" hasCustomPrompt="1"/>
+          </p:nvPr>
+        </p:nvSpPr>
+        <p:spPr>
+          <a:xfrm>
+            <a:off x="548640" y="365760"/>
+            <a:ext cx="8046720" cy="256032"/>
           </a:xfrm>
           <a:prstGeom prst="rect">
             <a:avLst/>
@@ -4180,9 +4160,9 @@
           <a:lstStyle>
             <a:lvl1pPr indent="0" marL="0">
               <a:buNone/>
-              <a:defRPr lang="en-US" sz="3000" dirty="0">
-                <a:solidFill>
-                  <a:srgbClr val="2A1B18"/>
+              <a:defRPr lang="en-US" sz="900" b="1" spc="200" kern="0" dirty="0">
+                <a:solidFill>
+                  <a:srgbClr val="FC6B59"/>
                 </a:solidFill>
               </a:defRPr>
             </a:lvl1pPr>
@@ -4192,14 +4172,14 @@
               <a:buNone/>
             </a:pPr>
             <a:r>
-              <a:rPr lang="en-US" sz="3000" dirty="0">
-                <a:solidFill>
-                  <a:srgbClr val="2A1B18"/>
-                </a:solidFill>
-              </a:rPr>
-              <a:t>Título do slide</a:t>
-            </a:r>
-            <a:endParaRPr lang="en-US" sz="3000" dirty="0"/>
+              <a:rPr lang="en-US" sz="900" b="1" spc="200" kern="0" dirty="0">
+                <a:solidFill>
+                  <a:srgbClr val="FC6B59"/>
+                </a:solidFill>
+              </a:rPr>
+              <a:t>KICKER DA SEÇÃO</a:t>
+            </a:r>
+            <a:endParaRPr lang="en-US" sz="900" dirty="0"/>
           </a:p>
         </p:txBody>
       </p:sp>
@@ -4208,7 +4188,54 @@
           <p:cNvPr id="3" name="Text 0"/>
           <p:cNvSpPr/>
           <p:nvPr>
-            <p:ph idx="101" hasCustomPrompt="1"/>
+            <p:ph idx="101" type="title" hasCustomPrompt="1"/>
+          </p:nvPr>
+        </p:nvSpPr>
+        <p:spPr>
+          <a:xfrm>
+            <a:off x="548640" y="621792"/>
+            <a:ext cx="8046720" cy="731520"/>
+          </a:xfrm>
+          <a:prstGeom prst="rect">
+            <a:avLst/>
+          </a:prstGeom>
+          <a:noFill/>
+          <a:ln/>
+        </p:spPr>
+        <p:txBody>
+          <a:bodyPr wrap="square" rtlCol="0"/>
+          <a:lstStyle>
+            <a:lvl1pPr algn="l" indent="0" marL="0">
+              <a:buNone/>
+              <a:defRPr lang="en-US" sz="2800" dirty="0">
+                <a:solidFill>
+                  <a:srgbClr val="2A1B18"/>
+                </a:solidFill>
+              </a:defRPr>
+            </a:lvl1pPr>
+          </a:lstStyle>
+          <a:p>
+            <a:pPr algn="l" indent="0" marL="0">
+              <a:buNone/>
+            </a:pPr>
+            <a:r>
+              <a:rPr lang="en-US" sz="2800" dirty="0">
+                <a:solidFill>
+                  <a:srgbClr val="2A1B18"/>
+                </a:solidFill>
+              </a:rPr>
+              <a:t>Título do slide</a:t>
+            </a:r>
+            <a:endParaRPr lang="en-US" sz="2800" dirty="0"/>
+          </a:p>
+        </p:txBody>
+      </p:sp>
+      <p:sp>
+        <p:nvSpPr>
+          <p:cNvPr id="4" name="Text 0"/>
+          <p:cNvSpPr/>
+          <p:nvPr>
+            <p:ph idx="102" hasCustomPrompt="1"/>
           </p:nvPr>
         </p:nvSpPr>
         <p:spPr>
@@ -4252,10 +4279,10 @@
       </p:sp>
       <p:sp>
         <p:nvSpPr>
-          <p:cNvPr id="4" name="Text 0"/>
+          <p:cNvPr id="5" name="Text 0"/>
           <p:cNvSpPr/>
           <p:nvPr>
-            <p:ph idx="102" type="body" hasCustomPrompt="1"/>
+            <p:ph idx="103" type="body" hasCustomPrompt="1"/>
           </p:nvPr>
         </p:nvSpPr>
         <p:spPr>
@@ -4299,7 +4326,7 @@
       </p:sp>
       <p:pic>
         <p:nvPicPr>
-          <p:cNvPr id="5" name="Image 0" descr="/tmp/claude-0/-home-user-espm/4ada8e6d-90e3-5cae-a464-bc23024773ff/scratchpad/deck/cora-color.png">    </p:cNvPr>
+          <p:cNvPr id="6" name="Image 0" descr="/tmp/claude-0/-home-user-espm/4ada8e6d-90e3-5cae-a464-bc23024773ff/scratchpad/deck/cora-color.png">    </p:cNvPr>
           <p:cNvPicPr>
             <a:picLocks noChangeAspect="1"/>
           </p:cNvPicPr>
@@ -4323,7 +4350,7 @@
       </p:pic>
       <p:sp>
         <p:nvSpPr>
-          <p:cNvPr id="6" name="Text 0"/>
+          <p:cNvPr id="7" name="Text 0"/>
           <p:cNvSpPr/>
           <p:nvPr/>
         </p:nvSpPr>
@@ -4783,13 +4810,13 @@
           <p:cNvPr id="4" name="Text 1"/>
           <p:cNvSpPr/>
           <p:nvPr>
-            <p:ph idx="102" type="title" hasCustomPrompt="1"/>
-          </p:nvPr>
-        </p:nvSpPr>
-        <p:spPr>
-          <a:xfrm>
-            <a:off x="548640" y="411480"/>
-            <a:ext cx="8046720" cy="868680"/>
+            <p:ph idx="102" type="body" hasCustomPrompt="1"/>
+          </p:nvPr>
+        </p:nvSpPr>
+        <p:spPr>
+          <a:xfrm>
+            <a:off x="548640" y="365760"/>
+            <a:ext cx="8046720" cy="256032"/>
           </a:xfrm>
           <a:prstGeom prst="rect">
             <a:avLst/>
@@ -4802,9 +4829,9 @@
           <a:lstStyle>
             <a:lvl1pPr indent="0" marL="0">
               <a:buNone/>
-              <a:defRPr lang="en-US" sz="3000" dirty="0">
-                <a:solidFill>
-                  <a:srgbClr val="FBF6F1"/>
+              <a:defRPr lang="en-US" sz="900" b="1" spc="200" kern="0" dirty="0">
+                <a:solidFill>
+                  <a:srgbClr val="FFD9CD"/>
                 </a:solidFill>
               </a:defRPr>
             </a:lvl1pPr>
@@ -4814,14 +4841,14 @@
               <a:buNone/>
             </a:pPr>
             <a:r>
-              <a:rPr lang="en-US" sz="3000" dirty="0">
-                <a:solidFill>
-                  <a:srgbClr val="FBF6F1"/>
-                </a:solidFill>
-              </a:rPr>
-              <a:t>Título do slide</a:t>
-            </a:r>
-            <a:endParaRPr lang="en-US" sz="3000" dirty="0"/>
+              <a:rPr lang="en-US" sz="900" b="1" spc="200" kern="0" dirty="0">
+                <a:solidFill>
+                  <a:srgbClr val="FFD9CD"/>
+                </a:solidFill>
+              </a:rPr>
+              <a:t>KICKER DA SEÇÃO</a:t>
+            </a:r>
+            <a:endParaRPr lang="en-US" sz="900" dirty="0"/>
           </a:p>
         </p:txBody>
       </p:sp>
@@ -4830,7 +4857,54 @@
           <p:cNvPr id="5" name="Text 1"/>
           <p:cNvSpPr/>
           <p:nvPr>
-            <p:ph idx="103" type="body" hasCustomPrompt="1"/>
+            <p:ph idx="103" type="title" hasCustomPrompt="1"/>
+          </p:nvPr>
+        </p:nvSpPr>
+        <p:spPr>
+          <a:xfrm>
+            <a:off x="548640" y="621792"/>
+            <a:ext cx="8046720" cy="731520"/>
+          </a:xfrm>
+          <a:prstGeom prst="rect">
+            <a:avLst/>
+          </a:prstGeom>
+          <a:noFill/>
+          <a:ln/>
+        </p:spPr>
+        <p:txBody>
+          <a:bodyPr wrap="square" rtlCol="0"/>
+          <a:lstStyle>
+            <a:lvl1pPr algn="l" indent="0" marL="0">
+              <a:buNone/>
+              <a:defRPr lang="en-US" sz="2800" dirty="0">
+                <a:solidFill>
+                  <a:srgbClr val="FBF6F1"/>
+                </a:solidFill>
+              </a:defRPr>
+            </a:lvl1pPr>
+          </a:lstStyle>
+          <a:p>
+            <a:pPr algn="l" indent="0" marL="0">
+              <a:buNone/>
+            </a:pPr>
+            <a:r>
+              <a:rPr lang="en-US" sz="2800" dirty="0">
+                <a:solidFill>
+                  <a:srgbClr val="FBF6F1"/>
+                </a:solidFill>
+              </a:rPr>
+              <a:t>Título do slide</a:t>
+            </a:r>
+            <a:endParaRPr lang="en-US" sz="2800" dirty="0"/>
+          </a:p>
+        </p:txBody>
+      </p:sp>
+      <p:sp>
+        <p:nvSpPr>
+          <p:cNvPr id="6" name="Text 1"/>
+          <p:cNvSpPr/>
+          <p:nvPr>
+            <p:ph idx="104" type="body" hasCustomPrompt="1"/>
           </p:nvPr>
         </p:nvSpPr>
         <p:spPr>
@@ -5284,94 +5358,36 @@
           <p:cNvPr id="2" name="Text 0"/>
           <p:cNvSpPr/>
           <p:nvPr>
-            <p:ph idx="102" type="title" hasCustomPrompt="1"/>
-          </p:nvPr>
-        </p:nvSpPr>
-        <p:spPr>
-          <a:xfrm>
-            <a:off x="548640" y="1463040"/>
-            <a:ext cx="3383280" cy="1828800"/>
-          </a:xfrm>
-          <a:prstGeom prst="rect">
-            <a:avLst/>
-          </a:prstGeom>
-          <a:noFill/>
-          <a:ln/>
-        </p:spPr>
-        <p:txBody>
-          <a:bodyPr wrap="square" lIns="0" tIns="0" rIns="0" bIns="0" rtlCol="0" anchor="ctr"/>
+            <p:ph idx="100" type="body" hasCustomPrompt="1"/>
+          </p:nvPr>
+        </p:nvSpPr>
+        <p:spPr>
+          <a:xfrm>
+            <a:off x="566928" y="4069080"/>
+            <a:ext cx="3291840" cy="457200"/>
+          </a:xfrm>
+          <a:prstGeom prst="rect">
+            <a:avLst/>
+          </a:prstGeom>
+          <a:noFill/>
+          <a:ln/>
+        </p:spPr>
+        <p:txBody>
+          <a:bodyPr wrap="square" lIns="0" tIns="0" rIns="0" bIns="0" rtlCol="0" anchor="t"/>
           <a:lstStyle/>
           <a:p>
             <a:pPr algn="l" indent="0" marL="0">
-              <a:lnSpc>
-                <a:spcPct val="95000"/>
-              </a:lnSpc>
-              <a:buNone/>
-            </a:pPr>
-            <a:r>
-              <a:rPr lang="en-US" sz="4000" dirty="0">
+              <a:buNone/>
+            </a:pPr>
+            <a:r>
+              <a:rPr lang="en-US" sz="1200" dirty="0">
                 <a:solidFill>
                   <a:srgbClr val="FBF6F1"/>
                 </a:solidFill>
               </a:rPr>
-              <a:t>Alguém</a:t>
-            </a:r>
-            <a:endParaRPr lang="en-US" sz="4000" dirty="0"/>
-          </a:p>
-          <a:p>
-            <a:pPr algn="l" indent="0" marL="0">
-              <a:lnSpc>
-                <a:spcPct val="95000"/>
-              </a:lnSpc>
-              <a:buNone/>
-            </a:pPr>
-            <a:r>
-              <a:rPr lang="en-US" sz="4000" dirty="0">
-                <a:solidFill>
-                  <a:srgbClr val="FB846D"/>
-                </a:solidFill>
-              </a:rPr>
-              <a:t>para ouvir.</a:t>
-            </a:r>
-            <a:endParaRPr lang="en-US" sz="4000" dirty="0"/>
-          </a:p>
-        </p:txBody>
-      </p:sp>
-      <p:sp>
-        <p:nvSpPr>
-          <p:cNvPr id="3" name="Text 0"/>
-          <p:cNvSpPr/>
-          <p:nvPr>
-            <p:ph idx="103" type="body" hasCustomPrompt="1"/>
-          </p:nvPr>
-        </p:nvSpPr>
-        <p:spPr>
-          <a:xfrm>
-            <a:off x="548640" y="3383280"/>
-            <a:ext cx="3291840" cy="731520"/>
-          </a:xfrm>
-          <a:prstGeom prst="rect">
-            <a:avLst/>
-          </a:prstGeom>
-          <a:noFill/>
-          <a:ln/>
-        </p:spPr>
-        <p:txBody>
-          <a:bodyPr wrap="square" lIns="0" tIns="0" rIns="0" bIns="0" rtlCol="0" anchor="t"/>
-          <a:lstStyle/>
-          <a:p>
-            <a:pPr indent="0" marL="0">
-              <a:buNone/>
-            </a:pPr>
-            <a:r>
-              <a:rPr lang="en-US" sz="1400" dirty="0">
-                <a:solidFill>
-                  <a:srgbClr val="C9B8B0"/>
-                </a:solidFill>
-              </a:rPr>
-              <a:t>Uma conversa acolhedora, próxima e de verdade.</a:t>
-            </a:r>
-            <a:endParaRPr lang="en-US" sz="1400" dirty="0"/>
+              <a:t>Projeto acadêmico ESPM · Gestão de Produtos · 2026</a:t>
+            </a:r>
+            <a:endParaRPr lang="en-US" sz="1200" dirty="0"/>
           </a:p>
         </p:txBody>
       </p:sp>
@@ -5677,13 +5693,13 @@
           <p:cNvPr id="2" name="Text 0"/>
           <p:cNvSpPr/>
           <p:nvPr>
-            <p:ph idx="100" type="title" hasCustomPrompt="1"/>
-          </p:nvPr>
-        </p:nvSpPr>
-        <p:spPr>
-          <a:xfrm>
-            <a:off x="548640" y="411480"/>
-            <a:ext cx="8046720" cy="868680"/>
+            <p:ph idx="100" type="body" hasCustomPrompt="1"/>
+          </p:nvPr>
+        </p:nvSpPr>
+        <p:spPr>
+          <a:xfrm>
+            <a:off x="548640" y="365760"/>
+            <a:ext cx="8046720" cy="256032"/>
           </a:xfrm>
           <a:prstGeom prst="rect">
             <a:avLst/>
@@ -5699,61 +5715,63 @@
               <a:buNone/>
             </a:pPr>
             <a:r>
-              <a:rPr lang="en-US" sz="3000" dirty="0">
+              <a:rPr lang="en-US" sz="900" b="1" spc="200" kern="0" dirty="0">
+                <a:solidFill>
+                  <a:srgbClr val="FC6B59"/>
+                </a:solidFill>
+              </a:rPr>
+              <a:t>COMPANHEIRA POR VÍDEO PARA QUEM MORA SOZINHO</a:t>
+            </a:r>
+            <a:endParaRPr lang="en-US" sz="900" dirty="0"/>
+          </a:p>
+        </p:txBody>
+      </p:sp>
+      <p:sp>
+        <p:nvSpPr>
+          <p:cNvPr id="3" name="Text 0"/>
+          <p:cNvSpPr/>
+          <p:nvPr>
+            <p:ph idx="101" type="title" hasCustomPrompt="1"/>
+          </p:nvPr>
+        </p:nvSpPr>
+        <p:spPr>
+          <a:xfrm>
+            <a:off x="548640" y="621792"/>
+            <a:ext cx="8046720" cy="731520"/>
+          </a:xfrm>
+          <a:prstGeom prst="rect">
+            <a:avLst/>
+          </a:prstGeom>
+          <a:noFill/>
+          <a:ln/>
+        </p:spPr>
+        <p:txBody>
+          <a:bodyPr wrap="square" lIns="0" tIns="0" rIns="0" bIns="0" rtlCol="0" anchor="ctr"/>
+          <a:lstStyle/>
+          <a:p>
+            <a:pPr algn="l" indent="0" marL="0">
+              <a:buNone/>
+            </a:pPr>
+            <a:r>
+              <a:rPr lang="en-US" sz="2800" dirty="0">
                 <a:solidFill>
                   <a:srgbClr val="2A1B18"/>
                 </a:solidFill>
               </a:rPr>
               <a:t>Sua mãe tem com quem conversar. </a:t>
             </a:r>
-            <a:pPr indent="0" marL="0">
-              <a:buNone/>
-            </a:pPr>
-            <a:r>
-              <a:rPr lang="en-US" sz="3000" i="1" dirty="0">
+            <a:pPr algn="l" indent="0" marL="0">
+              <a:buNone/>
+            </a:pPr>
+            <a:r>
+              <a:rPr lang="en-US" sz="2800" i="1" dirty="0">
                 <a:solidFill>
                   <a:srgbClr val="FB846D"/>
                 </a:solidFill>
               </a:rPr>
               <a:t>Todo dia.</a:t>
             </a:r>
-            <a:endParaRPr lang="en-US" sz="3000" dirty="0"/>
-          </a:p>
-        </p:txBody>
-      </p:sp>
-      <p:sp>
-        <p:nvSpPr>
-          <p:cNvPr id="3" name="eyebrow"/>
-          <p:cNvSpPr txBox="1"/>
-          <p:nvPr/>
-        </p:nvSpPr>
-        <p:spPr>
-          <a:xfrm>
-            <a:off x="548640" y="1417320"/>
-            <a:ext cx="3931920" cy="274320"/>
-          </a:xfrm>
-          <a:prstGeom prst="rect">
-            <a:avLst/>
-          </a:prstGeom>
-          <a:noFill/>
-          <a:ln/>
-        </p:spPr>
-        <p:txBody>
-          <a:bodyPr wrap="square" lIns="0" tIns="0" rIns="0" bIns="0" rtlCol="0" anchor="ctr"/>
-          <a:lstStyle/>
-          <a:p>
-            <a:pPr indent="0" marL="0">
-              <a:buNone/>
-            </a:pPr>
-            <a:r>
-              <a:rPr lang="en-US" sz="900" b="1" spc="200" kern="0" dirty="0">
-                <a:solidFill>
-                  <a:srgbClr val="FC6B59"/>
-                </a:solidFill>
-              </a:rPr>
-              <a:t>COMPANHEIRA POR VÍDEO PARA QUEM MORA SOZINHO</a:t>
-            </a:r>
-            <a:endParaRPr lang="en-US" sz="900" dirty="0"/>
+            <a:endParaRPr lang="en-US" sz="2800" dirty="0"/>
           </a:p>
         </p:txBody>
       </p:sp>
@@ -5765,7 +5783,7 @@
         </p:nvSpPr>
         <p:spPr>
           <a:xfrm>
-            <a:off x="548640" y="1783080"/>
+            <a:off x="548640" y="1600200"/>
             <a:ext cx="4572000" cy="1463040"/>
           </a:xfrm>
           <a:prstGeom prst="rect">
@@ -6100,13 +6118,13 @@
           <p:cNvPr id="2" name="Text 0"/>
           <p:cNvSpPr/>
           <p:nvPr>
-            <p:ph idx="100" type="title" hasCustomPrompt="1"/>
-          </p:nvPr>
-        </p:nvSpPr>
-        <p:spPr>
-          <a:xfrm>
-            <a:off x="548640" y="411480"/>
-            <a:ext cx="8046720" cy="868680"/>
+            <p:ph idx="100" type="body" hasCustomPrompt="1"/>
+          </p:nvPr>
+        </p:nvSpPr>
+        <p:spPr>
+          <a:xfrm>
+            <a:off x="548640" y="365760"/>
+            <a:ext cx="8046720" cy="256032"/>
           </a:xfrm>
           <a:prstGeom prst="rect">
             <a:avLst/>
@@ -6122,20 +6140,58 @@
               <a:buNone/>
             </a:pPr>
             <a:r>
-              <a:rPr lang="en-US" sz="3000" dirty="0">
+              <a:rPr lang="en-US" sz="900" b="1" spc="200" kern="0" dirty="0">
+                <a:solidFill>
+                  <a:srgbClr val="FC6B59"/>
+                </a:solidFill>
+              </a:rPr>
+              <a:t>O PROBLEMA</a:t>
+            </a:r>
+            <a:endParaRPr lang="en-US" sz="900" dirty="0"/>
+          </a:p>
+        </p:txBody>
+      </p:sp>
+      <p:sp>
+        <p:nvSpPr>
+          <p:cNvPr id="3" name="Text 0"/>
+          <p:cNvSpPr/>
+          <p:nvPr>
+            <p:ph idx="101" type="title" hasCustomPrompt="1"/>
+          </p:nvPr>
+        </p:nvSpPr>
+        <p:spPr>
+          <a:xfrm>
+            <a:off x="548640" y="621792"/>
+            <a:ext cx="8046720" cy="731520"/>
+          </a:xfrm>
+          <a:prstGeom prst="rect">
+            <a:avLst/>
+          </a:prstGeom>
+          <a:noFill/>
+          <a:ln/>
+        </p:spPr>
+        <p:txBody>
+          <a:bodyPr wrap="square" lIns="0" tIns="0" rIns="0" bIns="0" rtlCol="0" anchor="ctr"/>
+          <a:lstStyle/>
+          <a:p>
+            <a:pPr algn="l" indent="0" marL="0">
+              <a:buNone/>
+            </a:pPr>
+            <a:r>
+              <a:rPr lang="en-US" sz="2800" dirty="0">
                 <a:solidFill>
                   <a:srgbClr val="2A1B18"/>
                 </a:solidFill>
               </a:rPr>
               <a:t>Por que a Cora existe</a:t>
             </a:r>
-            <a:endParaRPr lang="en-US" sz="3000" dirty="0"/>
-          </a:p>
-        </p:txBody>
-      </p:sp>
-      <p:sp>
-        <p:nvSpPr>
-          <p:cNvPr id="3" name="stat 1"/>
+            <a:endParaRPr lang="en-US" sz="2800" dirty="0"/>
+          </a:p>
+        </p:txBody>
+      </p:sp>
+      <p:sp>
+        <p:nvSpPr>
+          <p:cNvPr id="4" name="stat 1"/>
           <p:cNvSpPr/>
           <p:nvPr/>
         </p:nvSpPr>
@@ -6169,7 +6225,7 @@
       </p:sp>
       <p:sp>
         <p:nvSpPr>
-          <p:cNvPr id="4" name="stat número 1"/>
+          <p:cNvPr id="5" name="stat número 1"/>
           <p:cNvSpPr txBox="1"/>
           <p:nvPr/>
         </p:nvSpPr>
@@ -6208,7 +6264,7 @@
       </p:sp>
       <p:sp>
         <p:nvSpPr>
-          <p:cNvPr id="5" name="stat texto 1"/>
+          <p:cNvPr id="6" name="stat texto 1"/>
           <p:cNvSpPr txBox="1"/>
           <p:nvPr/>
         </p:nvSpPr>
@@ -6244,7 +6300,7 @@
       </p:sp>
       <p:sp>
         <p:nvSpPr>
-          <p:cNvPr id="6" name="stat fonte 1"/>
+          <p:cNvPr id="7" name="stat fonte 1"/>
           <p:cNvSpPr txBox="1"/>
           <p:nvPr/>
         </p:nvSpPr>
@@ -6280,7 +6336,7 @@
       </p:sp>
       <p:sp>
         <p:nvSpPr>
-          <p:cNvPr id="7" name="stat 2"/>
+          <p:cNvPr id="8" name="stat 2"/>
           <p:cNvSpPr/>
           <p:nvPr/>
         </p:nvSpPr>
@@ -6314,7 +6370,7 @@
       </p:sp>
       <p:sp>
         <p:nvSpPr>
-          <p:cNvPr id="8" name="stat número 2"/>
+          <p:cNvPr id="9" name="stat número 2"/>
           <p:cNvSpPr txBox="1"/>
           <p:nvPr/>
         </p:nvSpPr>
@@ -6353,7 +6409,7 @@
       </p:sp>
       <p:sp>
         <p:nvSpPr>
-          <p:cNvPr id="9" name="stat texto 2"/>
+          <p:cNvPr id="10" name="stat texto 2"/>
           <p:cNvSpPr txBox="1"/>
           <p:nvPr/>
         </p:nvSpPr>
@@ -6389,7 +6445,7 @@
       </p:sp>
       <p:sp>
         <p:nvSpPr>
-          <p:cNvPr id="10" name="stat fonte 2"/>
+          <p:cNvPr id="11" name="stat fonte 2"/>
           <p:cNvSpPr txBox="1"/>
           <p:nvPr/>
         </p:nvSpPr>
@@ -6425,7 +6481,7 @@
       </p:sp>
       <p:sp>
         <p:nvSpPr>
-          <p:cNvPr id="11" name="stat 3"/>
+          <p:cNvPr id="12" name="stat 3"/>
           <p:cNvSpPr/>
           <p:nvPr/>
         </p:nvSpPr>
@@ -6459,7 +6515,7 @@
       </p:sp>
       <p:sp>
         <p:nvSpPr>
-          <p:cNvPr id="12" name="stat número 3"/>
+          <p:cNvPr id="13" name="stat número 3"/>
           <p:cNvSpPr txBox="1"/>
           <p:nvPr/>
         </p:nvSpPr>
@@ -6498,7 +6554,7 @@
       </p:sp>
       <p:sp>
         <p:nvSpPr>
-          <p:cNvPr id="13" name="stat texto 3"/>
+          <p:cNvPr id="14" name="stat texto 3"/>
           <p:cNvSpPr txBox="1"/>
           <p:nvPr/>
         </p:nvSpPr>
@@ -6534,7 +6590,7 @@
       </p:sp>
       <p:sp>
         <p:nvSpPr>
-          <p:cNvPr id="14" name="stat fonte 3"/>
+          <p:cNvPr id="15" name="stat fonte 3"/>
           <p:cNvSpPr txBox="1"/>
           <p:nvPr/>
         </p:nvSpPr>
@@ -6789,13 +6845,13 @@
           <p:cNvPr id="2" name="Text 0"/>
           <p:cNvSpPr/>
           <p:nvPr>
-            <p:ph idx="100" type="title" hasCustomPrompt="1"/>
-          </p:nvPr>
-        </p:nvSpPr>
-        <p:spPr>
-          <a:xfrm>
-            <a:off x="548640" y="411480"/>
-            <a:ext cx="8046720" cy="868680"/>
+            <p:ph idx="100" type="body" hasCustomPrompt="1"/>
+          </p:nvPr>
+        </p:nvSpPr>
+        <p:spPr>
+          <a:xfrm>
+            <a:off x="548640" y="365760"/>
+            <a:ext cx="8046720" cy="256032"/>
           </a:xfrm>
           <a:prstGeom prst="rect">
             <a:avLst/>
@@ -6811,20 +6867,58 @@
               <a:buNone/>
             </a:pPr>
             <a:r>
-              <a:rPr lang="en-US" sz="3000" dirty="0">
+              <a:rPr lang="en-US" sz="900" b="1" spc="200" kern="0" dirty="0">
+                <a:solidFill>
+                  <a:srgbClr val="FC6B59"/>
+                </a:solidFill>
+              </a:rPr>
+              <a:t>O PRODUTO</a:t>
+            </a:r>
+            <a:endParaRPr lang="en-US" sz="900" dirty="0"/>
+          </a:p>
+        </p:txBody>
+      </p:sp>
+      <p:sp>
+        <p:nvSpPr>
+          <p:cNvPr id="3" name="Text 0"/>
+          <p:cNvSpPr/>
+          <p:nvPr>
+            <p:ph idx="101" type="title" hasCustomPrompt="1"/>
+          </p:nvPr>
+        </p:nvSpPr>
+        <p:spPr>
+          <a:xfrm>
+            <a:off x="548640" y="621792"/>
+            <a:ext cx="8046720" cy="731520"/>
+          </a:xfrm>
+          <a:prstGeom prst="rect">
+            <a:avLst/>
+          </a:prstGeom>
+          <a:noFill/>
+          <a:ln/>
+        </p:spPr>
+        <p:txBody>
+          <a:bodyPr wrap="square" lIns="0" tIns="0" rIns="0" bIns="0" rtlCol="0" anchor="ctr"/>
+          <a:lstStyle/>
+          <a:p>
+            <a:pPr algn="l" indent="0" marL="0">
+              <a:buNone/>
+            </a:pPr>
+            <a:r>
+              <a:rPr lang="en-US" sz="2800" dirty="0">
                 <a:solidFill>
                   <a:srgbClr val="2A1B18"/>
                 </a:solidFill>
               </a:rPr>
               <a:t>Uma companheira que toma a iniciativa</a:t>
             </a:r>
-            <a:endParaRPr lang="en-US" sz="3000" dirty="0"/>
-          </a:p>
-        </p:txBody>
-      </p:sp>
-      <p:sp>
-        <p:nvSpPr>
-          <p:cNvPr id="3" name="subtítulo"/>
+            <a:endParaRPr lang="en-US" sz="2800" dirty="0"/>
+          </a:p>
+        </p:txBody>
+      </p:sp>
+      <p:sp>
+        <p:nvSpPr>
+          <p:cNvPr id="4" name="subtítulo"/>
           <p:cNvSpPr txBox="1"/>
           <p:nvPr/>
         </p:nvSpPr>
@@ -6860,7 +6954,7 @@
       </p:sp>
       <p:sp>
         <p:nvSpPr>
-          <p:cNvPr id="4" name="card Ela chama"/>
+          <p:cNvPr id="5" name="card Ela chama"/>
           <p:cNvSpPr/>
           <p:nvPr/>
         </p:nvSpPr>
@@ -6894,7 +6988,7 @@
       </p:sp>
       <p:sp>
         <p:nvSpPr>
-          <p:cNvPr id="5" name="num Ela chama"/>
+          <p:cNvPr id="6" name="num Ela chama"/>
           <p:cNvSpPr txBox="1"/>
           <p:nvPr/>
         </p:nvSpPr>
@@ -6933,7 +7027,7 @@
       </p:sp>
       <p:sp>
         <p:nvSpPr>
-          <p:cNvPr id="6" name="título Ela chama"/>
+          <p:cNvPr id="7" name="título Ela chama"/>
           <p:cNvSpPr txBox="1"/>
           <p:nvPr/>
         </p:nvSpPr>
@@ -6972,7 +7066,7 @@
       </p:sp>
       <p:sp>
         <p:nvSpPr>
-          <p:cNvPr id="7" name="texto Ela chama"/>
+          <p:cNvPr id="8" name="texto Ela chama"/>
           <p:cNvSpPr txBox="1"/>
           <p:nvPr/>
         </p:nvSpPr>
@@ -7008,7 +7102,7 @@
       </p:sp>
       <p:sp>
         <p:nvSpPr>
-          <p:cNvPr id="8" name="card Lembra da sua história"/>
+          <p:cNvPr id="9" name="card Lembra da sua história"/>
           <p:cNvSpPr/>
           <p:nvPr/>
         </p:nvSpPr>
@@ -7042,7 +7136,7 @@
       </p:sp>
       <p:sp>
         <p:nvSpPr>
-          <p:cNvPr id="9" name="num Lembra da sua história"/>
+          <p:cNvPr id="10" name="num Lembra da sua história"/>
           <p:cNvSpPr txBox="1"/>
           <p:nvPr/>
         </p:nvSpPr>
@@ -7081,7 +7175,7 @@
       </p:sp>
       <p:sp>
         <p:nvSpPr>
-          <p:cNvPr id="10" name="título Lembra da sua história"/>
+          <p:cNvPr id="11" name="título Lembra da sua história"/>
           <p:cNvSpPr txBox="1"/>
           <p:nvPr/>
         </p:nvSpPr>
@@ -7120,7 +7214,7 @@
       </p:sp>
       <p:sp>
         <p:nvSpPr>
-          <p:cNvPr id="11" name="texto Lembra da sua história"/>
+          <p:cNvPr id="12" name="texto Lembra da sua história"/>
           <p:cNvSpPr txBox="1"/>
           <p:nvPr/>
         </p:nvSpPr>
@@ -7156,7 +7250,7 @@
       </p:sp>
       <p:sp>
         <p:nvSpPr>
-          <p:cNvPr id="12" name="card Devolve ao convívio"/>
+          <p:cNvPr id="13" name="card Devolve ao convívio"/>
           <p:cNvSpPr/>
           <p:nvPr/>
         </p:nvSpPr>
@@ -7190,7 +7284,7 @@
       </p:sp>
       <p:sp>
         <p:nvSpPr>
-          <p:cNvPr id="13" name="num Devolve ao convívio"/>
+          <p:cNvPr id="14" name="num Devolve ao convívio"/>
           <p:cNvSpPr txBox="1"/>
           <p:nvPr/>
         </p:nvSpPr>
@@ -7229,7 +7323,7 @@
       </p:sp>
       <p:sp>
         <p:nvSpPr>
-          <p:cNvPr id="14" name="título Devolve ao convívio"/>
+          <p:cNvPr id="15" name="título Devolve ao convívio"/>
           <p:cNvSpPr txBox="1"/>
           <p:nvPr/>
         </p:nvSpPr>
@@ -7268,7 +7362,7 @@
       </p:sp>
       <p:sp>
         <p:nvSpPr>
-          <p:cNvPr id="15" name="texto Devolve ao convívio"/>
+          <p:cNvPr id="16" name="texto Devolve ao convívio"/>
           <p:cNvSpPr txBox="1"/>
           <p:nvPr/>
         </p:nvSpPr>
@@ -7304,7 +7398,7 @@
       </p:sp>
       <p:sp>
         <p:nvSpPr>
-          <p:cNvPr id="16" name="card Modo Família"/>
+          <p:cNvPr id="17" name="card Modo Família"/>
           <p:cNvSpPr/>
           <p:nvPr/>
         </p:nvSpPr>
@@ -7338,7 +7432,7 @@
       </p:sp>
       <p:sp>
         <p:nvSpPr>
-          <p:cNvPr id="17" name="num Modo Família"/>
+          <p:cNvPr id="18" name="num Modo Família"/>
           <p:cNvSpPr txBox="1"/>
           <p:nvPr/>
         </p:nvSpPr>
@@ -7377,7 +7471,7 @@
       </p:sp>
       <p:sp>
         <p:nvSpPr>
-          <p:cNvPr id="18" name="título Modo Família"/>
+          <p:cNvPr id="19" name="título Modo Família"/>
           <p:cNvSpPr txBox="1"/>
           <p:nvPr/>
         </p:nvSpPr>
@@ -7416,7 +7510,7 @@
       </p:sp>
       <p:sp>
         <p:nvSpPr>
-          <p:cNvPr id="19" name="texto Modo Família"/>
+          <p:cNvPr id="20" name="texto Modo Família"/>
           <p:cNvSpPr txBox="1"/>
           <p:nvPr/>
         </p:nvSpPr>
@@ -7525,13 +7619,13 @@
           <p:cNvPr id="2" name="Text 0"/>
           <p:cNvSpPr/>
           <p:nvPr>
-            <p:ph idx="100" type="title" hasCustomPrompt="1"/>
-          </p:nvPr>
-        </p:nvSpPr>
-        <p:spPr>
-          <a:xfrm>
-            <a:off x="548640" y="411480"/>
-            <a:ext cx="8046720" cy="868680"/>
+            <p:ph idx="100" type="body" hasCustomPrompt="1"/>
+          </p:nvPr>
+        </p:nvSpPr>
+        <p:spPr>
+          <a:xfrm>
+            <a:off x="548640" y="365760"/>
+            <a:ext cx="8046720" cy="256032"/>
           </a:xfrm>
           <a:prstGeom prst="rect">
             <a:avLst/>
@@ -7547,14 +7641,14 @@
               <a:buNone/>
             </a:pPr>
             <a:r>
-              <a:rPr lang="en-US" sz="3000" dirty="0">
-                <a:solidFill>
-                  <a:srgbClr val="2A1B18"/>
-                </a:solidFill>
-              </a:rPr>
-              <a:t>Ela chama. A conversa começa do lado de lá</a:t>
-            </a:r>
-            <a:endParaRPr lang="en-US" sz="3000" dirty="0"/>
+              <a:rPr lang="en-US" sz="900" b="1" spc="200" kern="0" dirty="0">
+                <a:solidFill>
+                  <a:srgbClr val="FC6B59"/>
+                </a:solidFill>
+              </a:rPr>
+              <a:t>COMO FUNCIONA</a:t>
+            </a:r>
+            <a:endParaRPr lang="en-US" sz="900" dirty="0"/>
           </a:p>
         </p:txBody>
       </p:sp>
@@ -7563,7 +7657,45 @@
           <p:cNvPr id="3" name="Text 0"/>
           <p:cNvSpPr/>
           <p:nvPr>
-            <p:ph idx="101" type="body" hasCustomPrompt="1"/>
+            <p:ph idx="101" type="title" hasCustomPrompt="1"/>
+          </p:nvPr>
+        </p:nvSpPr>
+        <p:spPr>
+          <a:xfrm>
+            <a:off x="548640" y="621792"/>
+            <a:ext cx="8046720" cy="731520"/>
+          </a:xfrm>
+          <a:prstGeom prst="rect">
+            <a:avLst/>
+          </a:prstGeom>
+          <a:noFill/>
+          <a:ln/>
+        </p:spPr>
+        <p:txBody>
+          <a:bodyPr wrap="square" lIns="0" tIns="0" rIns="0" bIns="0" rtlCol="0" anchor="ctr"/>
+          <a:lstStyle/>
+          <a:p>
+            <a:pPr algn="l" indent="0" marL="0">
+              <a:buNone/>
+            </a:pPr>
+            <a:r>
+              <a:rPr lang="en-US" sz="2800" dirty="0">
+                <a:solidFill>
+                  <a:srgbClr val="2A1B18"/>
+                </a:solidFill>
+              </a:rPr>
+              <a:t>Ela chama. A conversa começa do lado de lá</a:t>
+            </a:r>
+            <a:endParaRPr lang="en-US" sz="2800" dirty="0"/>
+          </a:p>
+        </p:txBody>
+      </p:sp>
+      <p:sp>
+        <p:nvSpPr>
+          <p:cNvPr id="4" name="Text 0"/>
+          <p:cNvSpPr/>
+          <p:nvPr>
+            <p:ph idx="102" type="body" hasCustomPrompt="1"/>
           </p:nvPr>
         </p:nvSpPr>
         <p:spPr>
@@ -7635,7 +7767,7 @@
       </p:sp>
       <p:sp>
         <p:nvSpPr>
-          <p:cNvPr id="4" name="chat"/>
+          <p:cNvPr id="5" name="chat"/>
           <p:cNvSpPr/>
           <p:nvPr/>
         </p:nvSpPr>
@@ -7669,7 +7801,7 @@
       </p:sp>
       <p:sp>
         <p:nvSpPr>
-          <p:cNvPr id="5" name="chat meta"/>
+          <p:cNvPr id="6" name="chat meta"/>
           <p:cNvSpPr txBox="1"/>
           <p:nvPr/>
         </p:nvSpPr>
@@ -7705,7 +7837,7 @@
       </p:sp>
       <p:sp>
         <p:nvSpPr>
-          <p:cNvPr id="6" name="balão Cora"/>
+          <p:cNvPr id="7" name="balão Cora"/>
           <p:cNvSpPr/>
           <p:nvPr/>
         </p:nvSpPr>
@@ -7732,7 +7864,7 @@
       </p:sp>
       <p:sp>
         <p:nvSpPr>
-          <p:cNvPr id="7" name="texto Cora"/>
+          <p:cNvPr id="8" name="texto Cora"/>
           <p:cNvSpPr txBox="1"/>
           <p:nvPr/>
         </p:nvSpPr>
@@ -7782,7 +7914,7 @@
       </p:sp>
       <p:sp>
         <p:nvSpPr>
-          <p:cNvPr id="8" name="balão Dona Lúcia"/>
+          <p:cNvPr id="9" name="balão Dona Lúcia"/>
           <p:cNvSpPr/>
           <p:nvPr/>
         </p:nvSpPr>
@@ -7809,7 +7941,7 @@
       </p:sp>
       <p:sp>
         <p:nvSpPr>
-          <p:cNvPr id="9" name="texto Dona Lúcia"/>
+          <p:cNvPr id="10" name="texto Dona Lúcia"/>
           <p:cNvSpPr txBox="1"/>
           <p:nvPr/>
         </p:nvSpPr>
@@ -7859,7 +7991,7 @@
       </p:sp>
       <p:sp>
         <p:nvSpPr>
-          <p:cNvPr id="10" name="balão Cora"/>
+          <p:cNvPr id="11" name="balão Cora"/>
           <p:cNvSpPr/>
           <p:nvPr/>
         </p:nvSpPr>
@@ -7886,7 +8018,7 @@
       </p:sp>
       <p:sp>
         <p:nvSpPr>
-          <p:cNvPr id="11" name="texto Cora"/>
+          <p:cNvPr id="12" name="texto Cora"/>
           <p:cNvSpPr txBox="1"/>
           <p:nvPr/>
         </p:nvSpPr>
@@ -7936,10 +8068,10 @@
       </p:sp>
       <p:sp>
         <p:nvSpPr>
-          <p:cNvPr id="12" name="Text 0"/>
+          <p:cNvPr id="13" name="Text 0"/>
           <p:cNvSpPr/>
           <p:nvPr>
-            <p:ph idx="102" type="body" hasCustomPrompt="1"/>
+            <p:ph idx="103" type="body" hasCustomPrompt="1"/>
           </p:nvPr>
         </p:nvSpPr>
         <p:spPr>
@@ -8042,13 +8174,13 @@
           <p:cNvPr id="2" name="Text 0"/>
           <p:cNvSpPr/>
           <p:nvPr>
-            <p:ph idx="100" type="title" hasCustomPrompt="1"/>
-          </p:nvPr>
-        </p:nvSpPr>
-        <p:spPr>
-          <a:xfrm>
-            <a:off x="548640" y="411480"/>
-            <a:ext cx="8046720" cy="868680"/>
+            <p:ph idx="100" type="body" hasCustomPrompt="1"/>
+          </p:nvPr>
+        </p:nvSpPr>
+        <p:spPr>
+          <a:xfrm>
+            <a:off x="548640" y="365760"/>
+            <a:ext cx="8046720" cy="256032"/>
           </a:xfrm>
           <a:prstGeom prst="rect">
             <a:avLst/>
@@ -8064,25 +8196,63 @@
               <a:buNone/>
             </a:pPr>
             <a:r>
-              <a:rPr lang="en-US" sz="3000" dirty="0">
+              <a:rPr lang="en-US" sz="900" b="1" spc="200" kern="0" dirty="0">
+                <a:solidFill>
+                  <a:srgbClr val="FC6B59"/>
+                </a:solidFill>
+              </a:rPr>
+              <a:t>COM ROSTO E VOZ</a:t>
+            </a:r>
+            <a:endParaRPr lang="en-US" sz="900" dirty="0"/>
+          </a:p>
+        </p:txBody>
+      </p:sp>
+      <p:sp>
+        <p:nvSpPr>
+          <p:cNvPr id="3" name="Text 0"/>
+          <p:cNvSpPr/>
+          <p:nvPr>
+            <p:ph idx="101" type="title" hasCustomPrompt="1"/>
+          </p:nvPr>
+        </p:nvSpPr>
+        <p:spPr>
+          <a:xfrm>
+            <a:off x="548640" y="621792"/>
+            <a:ext cx="8046720" cy="731520"/>
+          </a:xfrm>
+          <a:prstGeom prst="rect">
+            <a:avLst/>
+          </a:prstGeom>
+          <a:noFill/>
+          <a:ln/>
+        </p:spPr>
+        <p:txBody>
+          <a:bodyPr wrap="square" lIns="0" tIns="0" rIns="0" bIns="0" rtlCol="0" anchor="ctr"/>
+          <a:lstStyle/>
+          <a:p>
+            <a:pPr algn="l" indent="0" marL="0">
+              <a:buNone/>
+            </a:pPr>
+            <a:r>
+              <a:rPr lang="en-US" sz="2800" dirty="0">
                 <a:solidFill>
                   <a:srgbClr val="2A1B18"/>
                 </a:solidFill>
               </a:rPr>
               <a:t>Escolha quem vai conversar com a sua mãe</a:t>
             </a:r>
-            <a:endParaRPr lang="en-US" sz="3000" dirty="0"/>
+            <a:endParaRPr lang="en-US" sz="2800" dirty="0"/>
           </a:p>
         </p:txBody>
       </p:sp>
       <p:pic>
         <p:nvPicPr>
-          <p:cNvPr id="3" name="Image 0" descr="/tmp/claude-0/-home-user-espm/4ada8e6d-90e3-5cae-a464-bc23024773ff/scratchpad/deck/estudio.png">    </p:cNvPr>
+          <p:cNvPr id="4" name="Image 0" descr="/tmp/claude-0/-home-user-espm/4ada8e6d-90e3-5cae-a464-bc23024773ff/scratchpad/deck/estudio.png">    </p:cNvPr>
           <p:cNvPicPr>
             <a:picLocks noChangeAspect="1"/>
           </p:cNvPicPr>
           <p:nvPr>
-            <p:ph idx="101" hasCustomPrompt="1"/>
+            <p:ph idx="102" hasCustomPrompt="1"/>
           </p:nvPr>
         </p:nvPicPr>
         <p:blipFill>
@@ -8103,10 +8273,10 @@
       </p:pic>
       <p:sp>
         <p:nvSpPr>
-          <p:cNvPr id="4" name="Text 0"/>
+          <p:cNvPr id="5" name="Text 0"/>
           <p:cNvSpPr/>
           <p:nvPr>
-            <p:ph idx="102" type="body" hasCustomPrompt="1"/>
+            <p:ph idx="103" type="body" hasCustomPrompt="1"/>
           </p:nvPr>
         </p:nvSpPr>
         <p:spPr>
@@ -8214,13 +8384,13 @@
           <p:cNvPr id="2" name="Text 0"/>
           <p:cNvSpPr/>
           <p:nvPr>
-            <p:ph idx="100" type="title" hasCustomPrompt="1"/>
-          </p:nvPr>
-        </p:nvSpPr>
-        <p:spPr>
-          <a:xfrm>
-            <a:off x="548640" y="411480"/>
-            <a:ext cx="8046720" cy="868680"/>
+            <p:ph idx="100" type="body" hasCustomPrompt="1"/>
+          </p:nvPr>
+        </p:nvSpPr>
+        <p:spPr>
+          <a:xfrm>
+            <a:off x="548640" y="365760"/>
+            <a:ext cx="8046720" cy="256032"/>
           </a:xfrm>
           <a:prstGeom prst="rect">
             <a:avLst/>
@@ -8236,20 +8406,58 @@
               <a:buNone/>
             </a:pPr>
             <a:r>
-              <a:rPr lang="en-US" sz="3000" dirty="0">
+              <a:rPr lang="en-US" sz="900" b="1" spc="200" kern="0" dirty="0">
+                <a:solidFill>
+                  <a:srgbClr val="FC6B59"/>
+                </a:solidFill>
+              </a:rPr>
+              <a:t>PARA QUEM MORA SÓ</a:t>
+            </a:r>
+            <a:endParaRPr lang="en-US" sz="900" dirty="0"/>
+          </a:p>
+        </p:txBody>
+      </p:sp>
+      <p:sp>
+        <p:nvSpPr>
+          <p:cNvPr id="3" name="Text 0"/>
+          <p:cNvSpPr/>
+          <p:nvPr>
+            <p:ph idx="101" type="title" hasCustomPrompt="1"/>
+          </p:nvPr>
+        </p:nvSpPr>
+        <p:spPr>
+          <a:xfrm>
+            <a:off x="548640" y="621792"/>
+            <a:ext cx="8046720" cy="731520"/>
+          </a:xfrm>
+          <a:prstGeom prst="rect">
+            <a:avLst/>
+          </a:prstGeom>
+          <a:noFill/>
+          <a:ln/>
+        </p:spPr>
+        <p:txBody>
+          <a:bodyPr wrap="square" lIns="0" tIns="0" rIns="0" bIns="0" rtlCol="0" anchor="ctr"/>
+          <a:lstStyle/>
+          <a:p>
+            <a:pPr algn="l" indent="0" marL="0">
+              <a:buNone/>
+            </a:pPr>
+            <a:r>
+              <a:rPr lang="en-US" sz="2800" dirty="0">
                 <a:solidFill>
                   <a:srgbClr val="2A1B18"/>
                 </a:solidFill>
               </a:rPr>
               <a:t>Conversar não devia depender de pedir</a:t>
             </a:r>
-            <a:endParaRPr lang="en-US" sz="3000" dirty="0"/>
-          </a:p>
-        </p:txBody>
-      </p:sp>
-      <p:sp>
-        <p:nvSpPr>
-          <p:cNvPr id="3" name="cab dor"/>
+            <a:endParaRPr lang="en-US" sz="2800" dirty="0"/>
+          </a:p>
+        </p:txBody>
+      </p:sp>
+      <p:sp>
+        <p:nvSpPr>
+          <p:cNvPr id="4" name="cab dor"/>
           <p:cNvSpPr txBox="1"/>
           <p:nvPr/>
         </p:nvSpPr>
@@ -8285,7 +8493,7 @@
       </p:sp>
       <p:sp>
         <p:nvSpPr>
-          <p:cNvPr id="4" name="cab alívio"/>
+          <p:cNvPr id="5" name="cab alívio"/>
           <p:cNvSpPr txBox="1"/>
           <p:nvPr/>
         </p:nvSpPr>
@@ -8321,7 +8529,7 @@
       </p:sp>
       <p:sp>
         <p:nvSpPr>
-          <p:cNvPr id="5" name="par 1"/>
+          <p:cNvPr id="6" name="par 1"/>
           <p:cNvSpPr/>
           <p:nvPr/>
         </p:nvSpPr>
@@ -8355,7 +8563,7 @@
       </p:sp>
       <p:sp>
         <p:nvSpPr>
-          <p:cNvPr id="6" name="dor 1"/>
+          <p:cNvPr id="7" name="dor 1"/>
           <p:cNvSpPr txBox="1"/>
           <p:nvPr/>
         </p:nvSpPr>
@@ -8391,7 +8599,7 @@
       </p:sp>
       <p:sp>
         <p:nvSpPr>
-          <p:cNvPr id="7" name="ponto 9"/>
+          <p:cNvPr id="8" name="ponto 9"/>
           <p:cNvSpPr/>
           <p:nvPr/>
         </p:nvSpPr>
@@ -8416,7 +8624,7 @@
       </p:sp>
       <p:sp>
         <p:nvSpPr>
-          <p:cNvPr id="8" name="seta 1"/>
+          <p:cNvPr id="9" name="seta 1"/>
           <p:cNvSpPr txBox="1"/>
           <p:nvPr/>
         </p:nvSpPr>
@@ -8452,7 +8660,7 @@
       </p:sp>
       <p:sp>
         <p:nvSpPr>
-          <p:cNvPr id="9" name="alívio 1"/>
+          <p:cNvPr id="10" name="alívio 1"/>
           <p:cNvSpPr txBox="1"/>
           <p:nvPr/>
         </p:nvSpPr>
@@ -8491,7 +8699,7 @@
       </p:sp>
       <p:sp>
         <p:nvSpPr>
-          <p:cNvPr id="10" name="par 2"/>
+          <p:cNvPr id="11" name="par 2"/>
           <p:cNvSpPr/>
           <p:nvPr/>
         </p:nvSpPr>
@@ -8525,7 +8733,7 @@
       </p:sp>
       <p:sp>
         <p:nvSpPr>
-          <p:cNvPr id="11" name="dor 2"/>
+          <p:cNvPr id="12" name="dor 2"/>
           <p:cNvSpPr txBox="1"/>
           <p:nvPr/>
         </p:nvSpPr>
@@ -8561,7 +8769,7 @@
       </p:sp>
       <p:sp>
         <p:nvSpPr>
-          <p:cNvPr id="12" name="ponto 10"/>
+          <p:cNvPr id="13" name="ponto 10"/>
           <p:cNvSpPr/>
           <p:nvPr/>
         </p:nvSpPr>
@@ -8586,7 +8794,7 @@
       </p:sp>
       <p:sp>
         <p:nvSpPr>
-          <p:cNvPr id="13" name="seta 2"/>
+          <p:cNvPr id="14" name="seta 2"/>
           <p:cNvSpPr txBox="1"/>
           <p:nvPr/>
         </p:nvSpPr>
@@ -8622,7 +8830,7 @@
       </p:sp>
       <p:sp>
         <p:nvSpPr>
-          <p:cNvPr id="14" name="alívio 2"/>
+          <p:cNvPr id="15" name="alívio 2"/>
           <p:cNvSpPr txBox="1"/>
           <p:nvPr/>
         </p:nvSpPr>
@@ -8661,7 +8869,7 @@
       </p:sp>
       <p:sp>
         <p:nvSpPr>
-          <p:cNvPr id="15" name="par 3"/>
+          <p:cNvPr id="16" name="par 3"/>
           <p:cNvSpPr/>
           <p:nvPr/>
         </p:nvSpPr>
@@ -8695,7 +8903,7 @@
       </p:sp>
       <p:sp>
         <p:nvSpPr>
-          <p:cNvPr id="16" name="dor 3"/>
+          <p:cNvPr id="17" name="dor 3"/>
           <p:cNvSpPr txBox="1"/>
           <p:nvPr/>
         </p:nvSpPr>
@@ -8731,7 +8939,7 @@
       </p:sp>
       <p:sp>
         <p:nvSpPr>
-          <p:cNvPr id="17" name="ponto 11"/>
+          <p:cNvPr id="18" name="ponto 11"/>
           <p:cNvSpPr/>
           <p:nvPr/>
         </p:nvSpPr>
@@ -8756,7 +8964,7 @@
       </p:sp>
       <p:sp>
         <p:nvSpPr>
-          <p:cNvPr id="18" name="seta 3"/>
+          <p:cNvPr id="19" name="seta 3"/>
           <p:cNvSpPr txBox="1"/>
           <p:nvPr/>
         </p:nvSpPr>
@@ -8792,7 +9000,7 @@
       </p:sp>
       <p:sp>
         <p:nvSpPr>
-          <p:cNvPr id="19" name="alívio 3"/>
+          <p:cNvPr id="20" name="alívio 3"/>
           <p:cNvSpPr txBox="1"/>
           <p:nvPr/>
         </p:nvSpPr>
@@ -8831,7 +9039,7 @@
       </p:sp>
       <p:sp>
         <p:nvSpPr>
-          <p:cNvPr id="20" name="par 4"/>
+          <p:cNvPr id="21" name="par 4"/>
           <p:cNvSpPr/>
           <p:nvPr/>
         </p:nvSpPr>
@@ -8865,7 +9073,7 @@
       </p:sp>
       <p:sp>
         <p:nvSpPr>
-          <p:cNvPr id="21" name="dor 4"/>
+          <p:cNvPr id="22" name="dor 4"/>
           <p:cNvSpPr txBox="1"/>
           <p:nvPr/>
         </p:nvSpPr>
@@ -8901,7 +9109,7 @@
       </p:sp>
       <p:sp>
         <p:nvSpPr>
-          <p:cNvPr id="22" name="ponto 12"/>
+          <p:cNvPr id="23" name="ponto 12"/>
           <p:cNvSpPr/>
           <p:nvPr/>
         </p:nvSpPr>
@@ -8926,7 +9134,7 @@
       </p:sp>
       <p:sp>
         <p:nvSpPr>
-          <p:cNvPr id="23" name="seta 4"/>
+          <p:cNvPr id="24" name="seta 4"/>
           <p:cNvSpPr txBox="1"/>
           <p:nvPr/>
         </p:nvSpPr>
@@ -8962,7 +9170,7 @@
       </p:sp>
       <p:sp>
         <p:nvSpPr>
-          <p:cNvPr id="24" name="alívio 4"/>
+          <p:cNvPr id="25" name="alívio 4"/>
           <p:cNvSpPr txBox="1"/>
           <p:nvPr/>
         </p:nvSpPr>
@@ -9001,7 +9209,7 @@
       </p:sp>
       <p:sp>
         <p:nvSpPr>
-          <p:cNvPr id="25" name="par 5"/>
+          <p:cNvPr id="26" name="par 5"/>
           <p:cNvSpPr/>
           <p:nvPr/>
         </p:nvSpPr>
@@ -9035,7 +9243,7 @@
       </p:sp>
       <p:sp>
         <p:nvSpPr>
-          <p:cNvPr id="26" name="dor 5"/>
+          <p:cNvPr id="27" name="dor 5"/>
           <p:cNvSpPr txBox="1"/>
           <p:nvPr/>
         </p:nvSpPr>
@@ -9071,7 +9279,7 @@
       </p:sp>
       <p:sp>
         <p:nvSpPr>
-          <p:cNvPr id="27" name="ponto 13"/>
+          <p:cNvPr id="28" name="ponto 13"/>
           <p:cNvSpPr/>
           <p:nvPr/>
         </p:nvSpPr>
@@ -9096,7 +9304,7 @@
       </p:sp>
       <p:sp>
         <p:nvSpPr>
-          <p:cNvPr id="28" name="seta 5"/>
+          <p:cNvPr id="29" name="seta 5"/>
           <p:cNvSpPr txBox="1"/>
           <p:nvPr/>
         </p:nvSpPr>
@@ -9132,7 +9340,7 @@
       </p:sp>
       <p:sp>
         <p:nvSpPr>
-          <p:cNvPr id="29" name="alívio 5"/>
+          <p:cNvPr id="30" name="alívio 5"/>
           <p:cNvSpPr txBox="1"/>
           <p:nvPr/>
         </p:nvSpPr>
@@ -9471,13 +9679,13 @@
           <p:cNvPr id="2" name="Text 0"/>
           <p:cNvSpPr/>
           <p:nvPr>
-            <p:ph idx="100" type="title" hasCustomPrompt="1"/>
-          </p:nvPr>
-        </p:nvSpPr>
-        <p:spPr>
-          <a:xfrm>
-            <a:off x="548640" y="411480"/>
-            <a:ext cx="8046720" cy="868680"/>
+            <p:ph idx="100" type="body" hasCustomPrompt="1"/>
+          </p:nvPr>
+        </p:nvSpPr>
+        <p:spPr>
+          <a:xfrm>
+            <a:off x="548640" y="365760"/>
+            <a:ext cx="8046720" cy="256032"/>
           </a:xfrm>
           <a:prstGeom prst="rect">
             <a:avLst/>
@@ -9493,20 +9701,58 @@
               <a:buNone/>
             </a:pPr>
             <a:r>
-              <a:rPr lang="en-US" sz="3000" dirty="0">
+              <a:rPr lang="en-US" sz="900" b="1" spc="200" kern="0" dirty="0">
+                <a:solidFill>
+                  <a:srgbClr val="FC6B59"/>
+                </a:solidFill>
+              </a:rPr>
+              <a:t>GUIA</a:t>
+            </a:r>
+            <a:endParaRPr lang="en-US" sz="900" dirty="0"/>
+          </a:p>
+        </p:txBody>
+      </p:sp>
+      <p:sp>
+        <p:nvSpPr>
+          <p:cNvPr id="3" name="Text 0"/>
+          <p:cNvSpPr/>
+          <p:nvPr>
+            <p:ph idx="101" type="title" hasCustomPrompt="1"/>
+          </p:nvPr>
+        </p:nvSpPr>
+        <p:spPr>
+          <a:xfrm>
+            <a:off x="548640" y="621792"/>
+            <a:ext cx="8046720" cy="731520"/>
+          </a:xfrm>
+          <a:prstGeom prst="rect">
+            <a:avLst/>
+          </a:prstGeom>
+          <a:noFill/>
+          <a:ln/>
+        </p:spPr>
+        <p:txBody>
+          <a:bodyPr wrap="square" lIns="0" tIns="0" rIns="0" bIns="0" rtlCol="0" anchor="ctr"/>
+          <a:lstStyle/>
+          <a:p>
+            <a:pPr algn="l" indent="0" marL="0">
+              <a:buNone/>
+            </a:pPr>
+            <a:r>
+              <a:rPr lang="en-US" sz="2800" dirty="0">
                 <a:solidFill>
                   <a:srgbClr val="2A1B18"/>
                 </a:solidFill>
               </a:rPr>
               <a:t>Como usar este template</a:t>
             </a:r>
-            <a:endParaRPr lang="en-US" sz="3000" dirty="0"/>
-          </a:p>
-        </p:txBody>
-      </p:sp>
-      <p:sp>
-        <p:nvSpPr>
-          <p:cNvPr id="3" name="guia Capa"/>
+            <a:endParaRPr lang="en-US" sz="2800" dirty="0"/>
+          </a:p>
+        </p:txBody>
+      </p:sp>
+      <p:sp>
+        <p:nvSpPr>
+          <p:cNvPr id="4" name="guia Capa"/>
           <p:cNvSpPr/>
           <p:nvPr/>
         </p:nvSpPr>
@@ -9540,7 +9786,7 @@
       </p:sp>
       <p:sp>
         <p:nvSpPr>
-          <p:cNvPr id="4" name="ponto 1"/>
+          <p:cNvPr id="5" name="ponto 1"/>
           <p:cNvSpPr/>
           <p:nvPr/>
         </p:nvSpPr>
@@ -9565,7 +9811,7 @@
       </p:sp>
       <p:sp>
         <p:nvSpPr>
-          <p:cNvPr id="5" name="guia texto Capa"/>
+          <p:cNvPr id="6" name="guia texto Capa"/>
           <p:cNvSpPr txBox="1"/>
           <p:nvPr/>
         </p:nvSpPr>
@@ -9607,7 +9853,7 @@
                   <a:srgbClr val="6B5A55"/>
                 </a:solidFill>
               </a:rPr>
-              <a:t>Foto do key visual à direita, título em duas cores à esquerda.</a:t>
+              <a:t>Key visual em tela cheia. Só o crédito é editável.</a:t>
             </a:r>
             <a:endParaRPr lang="en-US" sz="1300" dirty="0"/>
           </a:p>
@@ -9615,7 +9861,7 @@
       </p:sp>
       <p:sp>
         <p:nvSpPr>
-          <p:cNvPr id="6" name="guia Divisória"/>
+          <p:cNvPr id="7" name="guia Divisória"/>
           <p:cNvSpPr/>
           <p:nvPr/>
         </p:nvSpPr>
@@ -9649,7 +9895,7 @@
       </p:sp>
       <p:sp>
         <p:nvSpPr>
-          <p:cNvPr id="7" name="ponto 2"/>
+          <p:cNvPr id="8" name="ponto 2"/>
           <p:cNvSpPr/>
           <p:nvPr/>
         </p:nvSpPr>
@@ -9674,7 +9920,7 @@
       </p:sp>
       <p:sp>
         <p:nvSpPr>
-          <p:cNvPr id="8" name="guia texto Divisória"/>
+          <p:cNvPr id="9" name="guia texto Divisória"/>
           <p:cNvSpPr txBox="1"/>
           <p:nvPr/>
         </p:nvSpPr>
@@ -9724,7 +9970,7 @@
       </p:sp>
       <p:sp>
         <p:nvSpPr>
-          <p:cNvPr id="9" name="guia Conteúdo"/>
+          <p:cNvPr id="10" name="guia Conteúdo"/>
           <p:cNvSpPr/>
           <p:nvPr/>
         </p:nvSpPr>
@@ -9758,7 +10004,7 @@
       </p:sp>
       <p:sp>
         <p:nvSpPr>
-          <p:cNvPr id="10" name="ponto 3"/>
+          <p:cNvPr id="11" name="ponto 3"/>
           <p:cNvSpPr/>
           <p:nvPr/>
         </p:nvSpPr>
@@ -9783,7 +10029,7 @@
       </p:sp>
       <p:sp>
         <p:nvSpPr>
-          <p:cNvPr id="11" name="guia texto Conteúdo"/>
+          <p:cNvPr id="12" name="guia texto Conteúdo"/>
           <p:cNvSpPr txBox="1"/>
           <p:nvPr/>
         </p:nvSpPr>
@@ -9833,7 +10079,7 @@
       </p:sp>
       <p:sp>
         <p:nvSpPr>
-          <p:cNvPr id="12" name="guia Só título"/>
+          <p:cNvPr id="13" name="guia Só título"/>
           <p:cNvSpPr/>
           <p:nvPr/>
         </p:nvSpPr>
@@ -9867,7 +10113,7 @@
       </p:sp>
       <p:sp>
         <p:nvSpPr>
-          <p:cNvPr id="13" name="ponto 4"/>
+          <p:cNvPr id="14" name="ponto 4"/>
           <p:cNvSpPr/>
           <p:nvPr/>
         </p:nvSpPr>
@@ -9892,7 +10138,7 @@
       </p:sp>
       <p:sp>
         <p:nvSpPr>
-          <p:cNvPr id="14" name="guia texto Só título"/>
+          <p:cNvPr id="15" name="guia texto Só título"/>
           <p:cNvSpPr txBox="1"/>
           <p:nvPr/>
         </p:nvSpPr>
@@ -9942,7 +10188,7 @@
       </p:sp>
       <p:sp>
         <p:nvSpPr>
-          <p:cNvPr id="15" name="guia Duas colunas"/>
+          <p:cNvPr id="16" name="guia Duas colunas"/>
           <p:cNvSpPr/>
           <p:nvPr/>
         </p:nvSpPr>
@@ -9976,7 +10222,7 @@
       </p:sp>
       <p:sp>
         <p:nvSpPr>
-          <p:cNvPr id="16" name="ponto 5"/>
+          <p:cNvPr id="17" name="ponto 5"/>
           <p:cNvSpPr/>
           <p:nvPr/>
         </p:nvSpPr>
@@ -10001,7 +10247,7 @@
       </p:sp>
       <p:sp>
         <p:nvSpPr>
-          <p:cNvPr id="17" name="guia texto Duas colunas"/>
+          <p:cNvPr id="18" name="guia texto Duas colunas"/>
           <p:cNvSpPr txBox="1"/>
           <p:nvPr/>
         </p:nvSpPr>
@@ -10051,7 +10297,7 @@
       </p:sp>
       <p:sp>
         <p:nvSpPr>
-          <p:cNvPr id="18" name="guia Imagem"/>
+          <p:cNvPr id="19" name="guia Imagem"/>
           <p:cNvSpPr/>
           <p:nvPr/>
         </p:nvSpPr>
@@ -10085,7 +10331,7 @@
       </p:sp>
       <p:sp>
         <p:nvSpPr>
-          <p:cNvPr id="19" name="ponto 6"/>
+          <p:cNvPr id="20" name="ponto 6"/>
           <p:cNvSpPr/>
           <p:nvPr/>
         </p:nvSpPr>
@@ -10110,7 +10356,7 @@
       </p:sp>
       <p:sp>
         <p:nvSpPr>
-          <p:cNvPr id="20" name="guia texto Imagem"/>
+          <p:cNvPr id="21" name="guia texto Imagem"/>
           <p:cNvSpPr txBox="1"/>
           <p:nvPr/>
         </p:nvSpPr>
@@ -10160,7 +10406,7 @@
       </p:sp>
       <p:sp>
         <p:nvSpPr>
-          <p:cNvPr id="21" name="guia Citação"/>
+          <p:cNvPr id="22" name="guia Citação"/>
           <p:cNvSpPr/>
           <p:nvPr/>
         </p:nvSpPr>
@@ -10194,7 +10440,7 @@
       </p:sp>
       <p:sp>
         <p:nvSpPr>
-          <p:cNvPr id="22" name="ponto 7"/>
+          <p:cNvPr id="23" name="ponto 7"/>
           <p:cNvSpPr/>
           <p:nvPr/>
         </p:nvSpPr>
@@ -10219,7 +10465,7 @@
       </p:sp>
       <p:sp>
         <p:nvSpPr>
-          <p:cNvPr id="23" name="guia texto Citação"/>
+          <p:cNvPr id="24" name="guia texto Citação"/>
           <p:cNvSpPr txBox="1"/>
           <p:nvPr/>
         </p:nvSpPr>
@@ -10269,7 +10515,7 @@
       </p:sp>
       <p:sp>
         <p:nvSpPr>
-          <p:cNvPr id="24" name="guia Coral e Fechamento"/>
+          <p:cNvPr id="25" name="guia Coral e Fechamento"/>
           <p:cNvSpPr/>
           <p:nvPr/>
         </p:nvSpPr>
@@ -10303,7 +10549,7 @@
       </p:sp>
       <p:sp>
         <p:nvSpPr>
-          <p:cNvPr id="25" name="ponto 8"/>
+          <p:cNvPr id="26" name="ponto 8"/>
           <p:cNvSpPr/>
           <p:nvPr/>
         </p:nvSpPr>
@@ -10328,7 +10574,7 @@
       </p:sp>
       <p:sp>
         <p:nvSpPr>
-          <p:cNvPr id="26" name="guia texto Coral e Fechamento"/>
+          <p:cNvPr id="27" name="guia texto Coral e Fechamento"/>
           <p:cNvSpPr txBox="1"/>
           <p:nvPr/>
         </p:nvSpPr>
@@ -10378,7 +10624,7 @@
       </p:sp>
       <p:sp>
         <p:nvSpPr>
-          <p:cNvPr id="27" name="dica"/>
+          <p:cNvPr id="28" name="dica"/>
           <p:cNvSpPr txBox="1"/>
           <p:nvPr/>
         </p:nvSpPr>
@@ -10487,13 +10733,13 @@
           <p:cNvPr id="2" name="Text 0"/>
           <p:cNvSpPr/>
           <p:nvPr>
-            <p:ph idx="100" type="title" hasCustomPrompt="1"/>
-          </p:nvPr>
-        </p:nvSpPr>
-        <p:spPr>
-          <a:xfrm>
-            <a:off x="548640" y="411480"/>
-            <a:ext cx="8046720" cy="868680"/>
+            <p:ph idx="100" type="body" hasCustomPrompt="1"/>
+          </p:nvPr>
+        </p:nvSpPr>
+        <p:spPr>
+          <a:xfrm>
+            <a:off x="548640" y="365760"/>
+            <a:ext cx="8046720" cy="256032"/>
           </a:xfrm>
           <a:prstGeom prst="rect">
             <a:avLst/>
@@ -10509,20 +10755,58 @@
               <a:buNone/>
             </a:pPr>
             <a:r>
-              <a:rPr lang="en-US" sz="3000" dirty="0">
+              <a:rPr lang="en-US" sz="900" b="1" spc="200" kern="0" dirty="0">
+                <a:solidFill>
+                  <a:srgbClr val="FC6B59"/>
+                </a:solidFill>
+              </a:rPr>
+              <a:t>MAIS DO QUE CONVERSA</a:t>
+            </a:r>
+            <a:endParaRPr lang="en-US" sz="900" dirty="0"/>
+          </a:p>
+        </p:txBody>
+      </p:sp>
+      <p:sp>
+        <p:nvSpPr>
+          <p:cNvPr id="3" name="Text 0"/>
+          <p:cNvSpPr/>
+          <p:nvPr>
+            <p:ph idx="101" type="title" hasCustomPrompt="1"/>
+          </p:nvPr>
+        </p:nvSpPr>
+        <p:spPr>
+          <a:xfrm>
+            <a:off x="548640" y="621792"/>
+            <a:ext cx="8046720" cy="731520"/>
+          </a:xfrm>
+          <a:prstGeom prst="rect">
+            <a:avLst/>
+          </a:prstGeom>
+          <a:noFill/>
+          <a:ln/>
+        </p:spPr>
+        <p:txBody>
+          <a:bodyPr wrap="square" lIns="0" tIns="0" rIns="0" bIns="0" rtlCol="0" anchor="ctr"/>
+          <a:lstStyle/>
+          <a:p>
+            <a:pPr algn="l" indent="0" marL="0">
+              <a:buNone/>
+            </a:pPr>
+            <a:r>
+              <a:rPr lang="en-US" sz="2800" dirty="0">
                 <a:solidFill>
                   <a:srgbClr val="2A1B18"/>
                 </a:solidFill>
               </a:rPr>
               <a:t>Uma ponte de volta para o mundo real</a:t>
             </a:r>
-            <a:endParaRPr lang="en-US" sz="3000" dirty="0"/>
-          </a:p>
-        </p:txBody>
-      </p:sp>
-      <p:sp>
-        <p:nvSpPr>
-          <p:cNvPr id="3" name="tile LIGAÇÃO COM ASSUNTO PRONTO"/>
+            <a:endParaRPr lang="en-US" sz="2800" dirty="0"/>
+          </a:p>
+        </p:txBody>
+      </p:sp>
+      <p:sp>
+        <p:nvSpPr>
+          <p:cNvPr id="4" name="tile LIGAÇÃO COM ASSUNTO PRONTO"/>
           <p:cNvSpPr/>
           <p:nvPr/>
         </p:nvSpPr>
@@ -10556,7 +10840,7 @@
       </p:sp>
       <p:sp>
         <p:nvSpPr>
-          <p:cNvPr id="4" name="tile texto LIGAÇÃO COM ASSUNTO PRONTO"/>
+          <p:cNvPr id="5" name="tile texto LIGAÇÃO COM ASSUNTO PRONTO"/>
           <p:cNvSpPr txBox="1"/>
           <p:nvPr/>
         </p:nvSpPr>
@@ -10629,7 +10913,7 @@
       </p:sp>
       <p:sp>
         <p:nvSpPr>
-          <p:cNvPr id="5" name="tile VIDA DO BAIRRO"/>
+          <p:cNvPr id="6" name="tile VIDA DO BAIRRO"/>
           <p:cNvSpPr/>
           <p:nvPr/>
         </p:nvSpPr>
@@ -10663,7 +10947,7 @@
       </p:sp>
       <p:sp>
         <p:nvSpPr>
-          <p:cNvPr id="6" name="tile texto VIDA DO BAIRRO"/>
+          <p:cNvPr id="7" name="tile texto VIDA DO BAIRRO"/>
           <p:cNvSpPr txBox="1"/>
           <p:nvPr/>
         </p:nvSpPr>
@@ -10736,7 +11020,7 @@
       </p:sp>
       <p:sp>
         <p:nvSpPr>
-          <p:cNvPr id="7" name="tile SER OUVIDO"/>
+          <p:cNvPr id="8" name="tile SER OUVIDO"/>
           <p:cNvSpPr/>
           <p:nvPr/>
         </p:nvSpPr>
@@ -10770,7 +11054,7 @@
       </p:sp>
       <p:sp>
         <p:nvSpPr>
-          <p:cNvPr id="8" name="tile texto SER OUVIDO"/>
+          <p:cNvPr id="9" name="tile texto SER OUVIDO"/>
           <p:cNvSpPr txBox="1"/>
           <p:nvPr/>
         </p:nvSpPr>
@@ -10843,7 +11127,7 @@
       </p:sp>
       <p:sp>
         <p:nvSpPr>
-          <p:cNvPr id="9" name="tile PERTENCER"/>
+          <p:cNvPr id="10" name="tile PERTENCER"/>
           <p:cNvSpPr/>
           <p:nvPr/>
         </p:nvSpPr>
@@ -10877,7 +11161,7 @@
       </p:sp>
       <p:sp>
         <p:nvSpPr>
-          <p:cNvPr id="10" name="tile texto PERTENCER"/>
+          <p:cNvPr id="11" name="tile texto PERTENCER"/>
           <p:cNvSpPr txBox="1"/>
           <p:nvPr/>
         </p:nvSpPr>
@@ -10950,7 +11234,7 @@
       </p:sp>
       <p:sp>
         <p:nvSpPr>
-          <p:cNvPr id="11" name="tile CUIDADO A TEMPO"/>
+          <p:cNvPr id="12" name="tile CUIDADO A TEMPO"/>
           <p:cNvSpPr/>
           <p:nvPr/>
         </p:nvSpPr>
@@ -10984,7 +11268,7 @@
       </p:sp>
       <p:sp>
         <p:nvSpPr>
-          <p:cNvPr id="12" name="tile texto CUIDADO A TEMPO"/>
+          <p:cNvPr id="13" name="tile texto CUIDADO A TEMPO"/>
           <p:cNvSpPr txBox="1"/>
           <p:nvPr/>
         </p:nvSpPr>
@@ -11130,13 +11414,13 @@
           <p:cNvPr id="2" name="Text 0"/>
           <p:cNvSpPr/>
           <p:nvPr>
-            <p:ph idx="100" type="title" hasCustomPrompt="1"/>
-          </p:nvPr>
-        </p:nvSpPr>
-        <p:spPr>
-          <a:xfrm>
-            <a:off x="548640" y="411480"/>
-            <a:ext cx="8046720" cy="868680"/>
+            <p:ph idx="100" type="body" hasCustomPrompt="1"/>
+          </p:nvPr>
+        </p:nvSpPr>
+        <p:spPr>
+          <a:xfrm>
+            <a:off x="548640" y="365760"/>
+            <a:ext cx="8046720" cy="256032"/>
           </a:xfrm>
           <a:prstGeom prst="rect">
             <a:avLst/>
@@ -11152,14 +11436,14 @@
               <a:buNone/>
             </a:pPr>
             <a:r>
-              <a:rPr lang="en-US" sz="3000" dirty="0">
-                <a:solidFill>
-                  <a:srgbClr val="2A1B18"/>
-                </a:solidFill>
-              </a:rPr>
-              <a:t>Saber que ela está bem, sem interrogatório</a:t>
-            </a:r>
-            <a:endParaRPr lang="en-US" sz="3000" dirty="0"/>
+              <a:rPr lang="en-US" sz="900" b="1" spc="200" kern="0" dirty="0">
+                <a:solidFill>
+                  <a:srgbClr val="FC6B59"/>
+                </a:solidFill>
+              </a:rPr>
+              <a:t>MODO FAMÍLIA</a:t>
+            </a:r>
+            <a:endParaRPr lang="en-US" sz="900" dirty="0"/>
           </a:p>
         </p:txBody>
       </p:sp>
@@ -11168,7 +11452,45 @@
           <p:cNvPr id="3" name="Text 0"/>
           <p:cNvSpPr/>
           <p:nvPr>
-            <p:ph idx="101" type="body" hasCustomPrompt="1"/>
+            <p:ph idx="101" type="title" hasCustomPrompt="1"/>
+          </p:nvPr>
+        </p:nvSpPr>
+        <p:spPr>
+          <a:xfrm>
+            <a:off x="548640" y="621792"/>
+            <a:ext cx="8046720" cy="731520"/>
+          </a:xfrm>
+          <a:prstGeom prst="rect">
+            <a:avLst/>
+          </a:prstGeom>
+          <a:noFill/>
+          <a:ln/>
+        </p:spPr>
+        <p:txBody>
+          <a:bodyPr wrap="square" lIns="0" tIns="0" rIns="0" bIns="0" rtlCol="0" anchor="ctr"/>
+          <a:lstStyle/>
+          <a:p>
+            <a:pPr algn="l" indent="0" marL="0">
+              <a:buNone/>
+            </a:pPr>
+            <a:r>
+              <a:rPr lang="en-US" sz="2800" dirty="0">
+                <a:solidFill>
+                  <a:srgbClr val="2A1B18"/>
+                </a:solidFill>
+              </a:rPr>
+              <a:t>Saber que ela está bem, sem interrogatório</a:t>
+            </a:r>
+            <a:endParaRPr lang="en-US" sz="2800" dirty="0"/>
+          </a:p>
+        </p:txBody>
+      </p:sp>
+      <p:sp>
+        <p:nvSpPr>
+          <p:cNvPr id="4" name="Text 0"/>
+          <p:cNvSpPr/>
+          <p:nvPr>
+            <p:ph idx="102" type="body" hasCustomPrompt="1"/>
           </p:nvPr>
         </p:nvSpPr>
         <p:spPr>
@@ -11260,7 +11582,7 @@
       </p:sp>
       <p:sp>
         <p:nvSpPr>
-          <p:cNvPr id="4" name="whatsapp"/>
+          <p:cNvPr id="5" name="whatsapp"/>
           <p:cNvSpPr/>
           <p:nvPr/>
         </p:nvSpPr>
@@ -11294,7 +11616,7 @@
       </p:sp>
       <p:sp>
         <p:nvSpPr>
-          <p:cNvPr id="5" name="wa meta"/>
+          <p:cNvPr id="6" name="wa meta"/>
           <p:cNvSpPr txBox="1"/>
           <p:nvPr/>
         </p:nvSpPr>
@@ -11330,7 +11652,7 @@
       </p:sp>
       <p:sp>
         <p:nvSpPr>
-          <p:cNvPr id="6" name="wa balão"/>
+          <p:cNvPr id="7" name="wa balão"/>
           <p:cNvSpPr/>
           <p:nvPr/>
         </p:nvSpPr>
@@ -11357,7 +11679,7 @@
       </p:sp>
       <p:sp>
         <p:nvSpPr>
-          <p:cNvPr id="7" name="wa texto"/>
+          <p:cNvPr id="8" name="wa texto"/>
           <p:cNvSpPr txBox="1"/>
           <p:nvPr/>
         </p:nvSpPr>
@@ -11458,7 +11780,7 @@
       </p:sp>
       <p:sp>
         <p:nvSpPr>
-          <p:cNvPr id="8" name="wa resposta"/>
+          <p:cNvPr id="9" name="wa resposta"/>
           <p:cNvSpPr/>
           <p:nvPr/>
         </p:nvSpPr>
@@ -11485,7 +11807,7 @@
       </p:sp>
       <p:sp>
         <p:nvSpPr>
-          <p:cNvPr id="9" name="wa resposta texto"/>
+          <p:cNvPr id="10" name="wa resposta texto"/>
           <p:cNvSpPr txBox="1"/>
           <p:nvPr/>
         </p:nvSpPr>
@@ -11521,10 +11843,10 @@
       </p:sp>
       <p:sp>
         <p:nvSpPr>
-          <p:cNvPr id="10" name="Text 0"/>
+          <p:cNvPr id="11" name="Text 0"/>
           <p:cNvSpPr/>
           <p:nvPr>
-            <p:ph idx="102" type="body" hasCustomPrompt="1"/>
+            <p:ph idx="103" type="body" hasCustomPrompt="1"/>
           </p:nvPr>
         </p:nvSpPr>
         <p:spPr>
@@ -11627,13 +11949,13 @@
           <p:cNvPr id="2" name="Text 0"/>
           <p:cNvSpPr/>
           <p:nvPr>
-            <p:ph idx="100" type="title" hasCustomPrompt="1"/>
-          </p:nvPr>
-        </p:nvSpPr>
-        <p:spPr>
-          <a:xfrm>
-            <a:off x="548640" y="411480"/>
-            <a:ext cx="8046720" cy="868680"/>
+            <p:ph idx="100" type="body" hasCustomPrompt="1"/>
+          </p:nvPr>
+        </p:nvSpPr>
+        <p:spPr>
+          <a:xfrm>
+            <a:off x="548640" y="365760"/>
+            <a:ext cx="8046720" cy="256032"/>
           </a:xfrm>
           <a:prstGeom prst="rect">
             <a:avLst/>
@@ -11649,20 +11971,58 @@
               <a:buNone/>
             </a:pPr>
             <a:r>
-              <a:rPr lang="en-US" sz="3000" dirty="0">
+              <a:rPr lang="en-US" sz="900" b="1" spc="200" kern="0" dirty="0">
+                <a:solidFill>
+                  <a:srgbClr val="FC6B59"/>
+                </a:solidFill>
+              </a:rPr>
+              <a:t>PLANOS</a:t>
+            </a:r>
+            <a:endParaRPr lang="en-US" sz="900" dirty="0"/>
+          </a:p>
+        </p:txBody>
+      </p:sp>
+      <p:sp>
+        <p:nvSpPr>
+          <p:cNvPr id="3" name="Text 0"/>
+          <p:cNvSpPr/>
+          <p:nvPr>
+            <p:ph idx="101" type="title" hasCustomPrompt="1"/>
+          </p:nvPr>
+        </p:nvSpPr>
+        <p:spPr>
+          <a:xfrm>
+            <a:off x="548640" y="621792"/>
+            <a:ext cx="8046720" cy="731520"/>
+          </a:xfrm>
+          <a:prstGeom prst="rect">
+            <a:avLst/>
+          </a:prstGeom>
+          <a:noFill/>
+          <a:ln/>
+        </p:spPr>
+        <p:txBody>
+          <a:bodyPr wrap="square" lIns="0" tIns="0" rIns="0" bIns="0" rtlCol="0" anchor="ctr"/>
+          <a:lstStyle/>
+          <a:p>
+            <a:pPr algn="l" indent="0" marL="0">
+              <a:buNone/>
+            </a:pPr>
+            <a:r>
+              <a:rPr lang="en-US" sz="2800" dirty="0">
                 <a:solidFill>
                   <a:srgbClr val="2A1B18"/>
                 </a:solidFill>
               </a:rPr>
               <a:t>Uma assinatura para a família toda</a:t>
             </a:r>
-            <a:endParaRPr lang="en-US" sz="3000" dirty="0"/>
-          </a:p>
-        </p:txBody>
-      </p:sp>
-      <p:sp>
-        <p:nvSpPr>
-          <p:cNvPr id="3" name="subtítulo planos"/>
+            <a:endParaRPr lang="en-US" sz="2800" dirty="0"/>
+          </a:p>
+        </p:txBody>
+      </p:sp>
+      <p:sp>
+        <p:nvSpPr>
+          <p:cNvPr id="4" name="subtítulo planos"/>
           <p:cNvSpPr txBox="1"/>
           <p:nvPr/>
         </p:nvSpPr>
@@ -11698,7 +12058,7 @@
       </p:sp>
       <p:sp>
         <p:nvSpPr>
-          <p:cNvPr id="4" name="painel planos"/>
+          <p:cNvPr id="5" name="painel planos"/>
           <p:cNvSpPr/>
           <p:nvPr/>
         </p:nvSpPr>
@@ -11732,7 +12092,7 @@
       </p:sp>
       <p:sp>
         <p:nvSpPr>
-          <p:cNvPr id="5" name="plano nome"/>
+          <p:cNvPr id="6" name="plano nome"/>
           <p:cNvSpPr txBox="1"/>
           <p:nvPr/>
         </p:nvSpPr>
@@ -11771,7 +12131,7 @@
       </p:sp>
       <p:sp>
         <p:nvSpPr>
-          <p:cNvPr id="6" name="plano preço"/>
+          <p:cNvPr id="7" name="plano preço"/>
           <p:cNvSpPr txBox="1"/>
           <p:nvPr/>
         </p:nvSpPr>
@@ -11824,7 +12184,7 @@
       </p:sp>
       <p:sp>
         <p:nvSpPr>
-          <p:cNvPr id="7" name="plano nota"/>
+          <p:cNvPr id="8" name="plano nota"/>
           <p:cNvSpPr txBox="1"/>
           <p:nvPr/>
         </p:nvSpPr>
@@ -11860,7 +12220,7 @@
       </p:sp>
       <p:sp>
         <p:nvSpPr>
-          <p:cNvPr id="8" name="ponto 14"/>
+          <p:cNvPr id="9" name="ponto 14"/>
           <p:cNvSpPr/>
           <p:nvPr/>
         </p:nvSpPr>
@@ -11885,7 +12245,7 @@
       </p:sp>
       <p:sp>
         <p:nvSpPr>
-          <p:cNvPr id="9" name="check"/>
+          <p:cNvPr id="10" name="check"/>
           <p:cNvSpPr txBox="1"/>
           <p:nvPr/>
         </p:nvSpPr>
@@ -11921,7 +12281,7 @@
       </p:sp>
       <p:sp>
         <p:nvSpPr>
-          <p:cNvPr id="10" name="item"/>
+          <p:cNvPr id="11" name="item"/>
           <p:cNvSpPr txBox="1"/>
           <p:nvPr/>
         </p:nvSpPr>
@@ -11957,7 +12317,7 @@
       </p:sp>
       <p:sp>
         <p:nvSpPr>
-          <p:cNvPr id="11" name="ponto 15"/>
+          <p:cNvPr id="12" name="ponto 15"/>
           <p:cNvSpPr/>
           <p:nvPr/>
         </p:nvSpPr>
@@ -11982,7 +12342,7 @@
       </p:sp>
       <p:sp>
         <p:nvSpPr>
-          <p:cNvPr id="12" name="check"/>
+          <p:cNvPr id="13" name="check"/>
           <p:cNvSpPr txBox="1"/>
           <p:nvPr/>
         </p:nvSpPr>
@@ -12018,7 +12378,7 @@
       </p:sp>
       <p:sp>
         <p:nvSpPr>
-          <p:cNvPr id="13" name="item"/>
+          <p:cNvPr id="14" name="item"/>
           <p:cNvSpPr txBox="1"/>
           <p:nvPr/>
         </p:nvSpPr>
@@ -12054,7 +12414,7 @@
       </p:sp>
       <p:sp>
         <p:nvSpPr>
-          <p:cNvPr id="14" name="ponto 16"/>
+          <p:cNvPr id="15" name="ponto 16"/>
           <p:cNvSpPr/>
           <p:nvPr/>
         </p:nvSpPr>
@@ -12079,7 +12439,7 @@
       </p:sp>
       <p:sp>
         <p:nvSpPr>
-          <p:cNvPr id="15" name="check"/>
+          <p:cNvPr id="16" name="check"/>
           <p:cNvSpPr txBox="1"/>
           <p:nvPr/>
         </p:nvSpPr>
@@ -12115,7 +12475,7 @@
       </p:sp>
       <p:sp>
         <p:nvSpPr>
-          <p:cNvPr id="16" name="item"/>
+          <p:cNvPr id="17" name="item"/>
           <p:cNvSpPr txBox="1"/>
           <p:nvPr/>
         </p:nvSpPr>
@@ -12151,7 +12511,7 @@
       </p:sp>
       <p:sp>
         <p:nvSpPr>
-          <p:cNvPr id="17" name="ponto 17"/>
+          <p:cNvPr id="18" name="ponto 17"/>
           <p:cNvSpPr/>
           <p:nvPr/>
         </p:nvSpPr>
@@ -12176,7 +12536,7 @@
       </p:sp>
       <p:sp>
         <p:nvSpPr>
-          <p:cNvPr id="18" name="check"/>
+          <p:cNvPr id="19" name="check"/>
           <p:cNvSpPr txBox="1"/>
           <p:nvPr/>
         </p:nvSpPr>
@@ -12212,7 +12572,7 @@
       </p:sp>
       <p:sp>
         <p:nvSpPr>
-          <p:cNvPr id="19" name="item"/>
+          <p:cNvPr id="20" name="item"/>
           <p:cNvSpPr txBox="1"/>
           <p:nvPr/>
         </p:nvSpPr>
@@ -12248,7 +12608,7 @@
       </p:sp>
       <p:sp>
         <p:nvSpPr>
-          <p:cNvPr id="20" name="ponto 18"/>
+          <p:cNvPr id="21" name="ponto 18"/>
           <p:cNvSpPr/>
           <p:nvPr/>
         </p:nvSpPr>
@@ -12273,7 +12633,7 @@
       </p:sp>
       <p:sp>
         <p:nvSpPr>
-          <p:cNvPr id="21" name="check"/>
+          <p:cNvPr id="22" name="check"/>
           <p:cNvSpPr txBox="1"/>
           <p:nvPr/>
         </p:nvSpPr>
@@ -12309,7 +12669,7 @@
       </p:sp>
       <p:sp>
         <p:nvSpPr>
-          <p:cNvPr id="22" name="item"/>
+          <p:cNvPr id="23" name="item"/>
           <p:cNvSpPr txBox="1"/>
           <p:nvPr/>
         </p:nvSpPr>
@@ -12418,13 +12778,13 @@
           <p:cNvPr id="2" name="Text 1"/>
           <p:cNvSpPr/>
           <p:nvPr>
-            <p:ph idx="102" type="title" hasCustomPrompt="1"/>
-          </p:nvPr>
-        </p:nvSpPr>
-        <p:spPr>
-          <a:xfrm>
-            <a:off x="548640" y="411480"/>
-            <a:ext cx="8046720" cy="868680"/>
+            <p:ph idx="102" type="body" hasCustomPrompt="1"/>
+          </p:nvPr>
+        </p:nvSpPr>
+        <p:spPr>
+          <a:xfrm>
+            <a:off x="548640" y="365760"/>
+            <a:ext cx="8046720" cy="256032"/>
           </a:xfrm>
           <a:prstGeom prst="rect">
             <a:avLst/>
@@ -12440,20 +12800,58 @@
               <a:buNone/>
             </a:pPr>
             <a:r>
-              <a:rPr lang="en-US" sz="3000" dirty="0">
+              <a:rPr lang="en-US" sz="900" b="1" spc="200" kern="0" dirty="0">
+                <a:solidFill>
+                  <a:srgbClr val="FFD9CD"/>
+                </a:solidFill>
+              </a:rPr>
+              <a:t>TRANSPARENTE POR PRINCÍPIO</a:t>
+            </a:r>
+            <a:endParaRPr lang="en-US" sz="900" dirty="0"/>
+          </a:p>
+        </p:txBody>
+      </p:sp>
+      <p:sp>
+        <p:nvSpPr>
+          <p:cNvPr id="3" name="Text 1"/>
+          <p:cNvSpPr/>
+          <p:nvPr>
+            <p:ph idx="103" type="title" hasCustomPrompt="1"/>
+          </p:nvPr>
+        </p:nvSpPr>
+        <p:spPr>
+          <a:xfrm>
+            <a:off x="548640" y="621792"/>
+            <a:ext cx="8046720" cy="731520"/>
+          </a:xfrm>
+          <a:prstGeom prst="rect">
+            <a:avLst/>
+          </a:prstGeom>
+          <a:noFill/>
+          <a:ln/>
+        </p:spPr>
+        <p:txBody>
+          <a:bodyPr wrap="square" lIns="0" tIns="0" rIns="0" bIns="0" rtlCol="0" anchor="ctr"/>
+          <a:lstStyle/>
+          <a:p>
+            <a:pPr algn="l" indent="0" marL="0">
+              <a:buNone/>
+            </a:pPr>
+            <a:r>
+              <a:rPr lang="en-US" sz="2800" dirty="0">
                 <a:solidFill>
                   <a:srgbClr val="FBF6F1"/>
                 </a:solidFill>
               </a:rPr>
               <a:t>Companhia de verdade, sem fingir ser gente</a:t>
             </a:r>
-            <a:endParaRPr lang="en-US" sz="3000" dirty="0"/>
-          </a:p>
-        </p:txBody>
-      </p:sp>
-      <p:sp>
-        <p:nvSpPr>
-          <p:cNvPr id="3" name="não 1"/>
+            <a:endParaRPr lang="en-US" sz="2800" dirty="0"/>
+          </a:p>
+        </p:txBody>
+      </p:sp>
+      <p:sp>
+        <p:nvSpPr>
+          <p:cNvPr id="4" name="não 1"/>
           <p:cNvSpPr txBox="1"/>
           <p:nvPr/>
         </p:nvSpPr>
@@ -12489,7 +12887,7 @@
       </p:sp>
       <p:sp>
         <p:nvSpPr>
-          <p:cNvPr id="4" name="não texto 1"/>
+          <p:cNvPr id="5" name="não texto 1"/>
           <p:cNvSpPr txBox="1"/>
           <p:nvPr/>
         </p:nvSpPr>
@@ -12542,7 +12940,7 @@
       </p:sp>
       <p:sp>
         <p:nvSpPr>
-          <p:cNvPr id="5" name="não 2"/>
+          <p:cNvPr id="6" name="não 2"/>
           <p:cNvSpPr txBox="1"/>
           <p:nvPr/>
         </p:nvSpPr>
@@ -12578,7 +12976,7 @@
       </p:sp>
       <p:sp>
         <p:nvSpPr>
-          <p:cNvPr id="6" name="não texto 2"/>
+          <p:cNvPr id="7" name="não texto 2"/>
           <p:cNvSpPr txBox="1"/>
           <p:nvPr/>
         </p:nvSpPr>
@@ -12631,7 +13029,7 @@
       </p:sp>
       <p:sp>
         <p:nvSpPr>
-          <p:cNvPr id="7" name="não 3"/>
+          <p:cNvPr id="8" name="não 3"/>
           <p:cNvSpPr txBox="1"/>
           <p:nvPr/>
         </p:nvSpPr>
@@ -12667,7 +13065,7 @@
       </p:sp>
       <p:sp>
         <p:nvSpPr>
-          <p:cNvPr id="8" name="não texto 3"/>
+          <p:cNvPr id="9" name="não texto 3"/>
           <p:cNvSpPr txBox="1"/>
           <p:nvPr/>
         </p:nvSpPr>
@@ -12720,7 +13118,7 @@
       </p:sp>
       <p:sp>
         <p:nvSpPr>
-          <p:cNvPr id="9" name="não 4"/>
+          <p:cNvPr id="10" name="não 4"/>
           <p:cNvSpPr txBox="1"/>
           <p:nvPr/>
         </p:nvSpPr>
@@ -12756,7 +13154,7 @@
       </p:sp>
       <p:sp>
         <p:nvSpPr>
-          <p:cNvPr id="10" name="não texto 4"/>
+          <p:cNvPr id="11" name="não texto 4"/>
           <p:cNvSpPr txBox="1"/>
           <p:nvPr/>
         </p:nvSpPr>
@@ -12809,10 +13207,10 @@
       </p:sp>
       <p:sp>
         <p:nvSpPr>
-          <p:cNvPr id="11" name="Text 1"/>
+          <p:cNvPr id="12" name="Text 1"/>
           <p:cNvSpPr/>
           <p:nvPr>
-            <p:ph idx="103" type="body" hasCustomPrompt="1"/>
+            <p:ph idx="104" type="body" hasCustomPrompt="1"/>
           </p:nvPr>
         </p:nvSpPr>
         <p:spPr>
@@ -13259,13 +13657,13 @@
           <p:cNvPr id="3" name="Text 0"/>
           <p:cNvSpPr/>
           <p:nvPr>
-            <p:ph idx="100" type="title" hasCustomPrompt="1"/>
-          </p:nvPr>
-        </p:nvSpPr>
-        <p:spPr>
-          <a:xfrm>
-            <a:off x="548640" y="411480"/>
-            <a:ext cx="8046720" cy="868680"/>
+            <p:ph idx="100" type="body" hasCustomPrompt="1"/>
+          </p:nvPr>
+        </p:nvSpPr>
+        <p:spPr>
+          <a:xfrm>
+            <a:off x="548640" y="365760"/>
+            <a:ext cx="8046720" cy="256032"/>
           </a:xfrm>
           <a:prstGeom prst="rect">
             <a:avLst/>
@@ -13280,7 +13678,7 @@
             <a:pPr indent="0" marL="0">
               <a:buNone/>
             </a:pPr>
-            <a:endParaRPr lang="en-US" sz="3000" dirty="0"/>
+            <a:endParaRPr lang="en-US" sz="900" dirty="0"/>
           </a:p>
         </p:txBody>
       </p:sp>
@@ -13289,7 +13687,37 @@
           <p:cNvPr id="4" name="Text 0"/>
           <p:cNvSpPr/>
           <p:nvPr>
-            <p:ph idx="101" type="body" hasCustomPrompt="1"/>
+            <p:ph idx="101" type="title" hasCustomPrompt="1"/>
+          </p:nvPr>
+        </p:nvSpPr>
+        <p:spPr>
+          <a:xfrm>
+            <a:off x="548640" y="621792"/>
+            <a:ext cx="8046720" cy="731520"/>
+          </a:xfrm>
+          <a:prstGeom prst="rect">
+            <a:avLst/>
+          </a:prstGeom>
+          <a:noFill/>
+          <a:ln/>
+        </p:spPr>
+        <p:txBody>
+          <a:bodyPr wrap="square" lIns="0" tIns="0" rIns="0" bIns="0" rtlCol="0" anchor="ctr"/>
+          <a:lstStyle/>
+          <a:p>
+            <a:pPr algn="l" indent="0" marL="0">
+              <a:buNone/>
+            </a:pPr>
+            <a:endParaRPr lang="en-US" sz="2800" dirty="0"/>
+          </a:p>
+        </p:txBody>
+      </p:sp>
+      <p:sp>
+        <p:nvSpPr>
+          <p:cNvPr id="5" name="Text 0"/>
+          <p:cNvSpPr/>
+          <p:nvPr>
+            <p:ph idx="102" type="body" hasCustomPrompt="1"/>
           </p:nvPr>
         </p:nvSpPr>
         <p:spPr>
@@ -13392,13 +13820,13 @@
           <p:cNvPr id="3" name="Text 0"/>
           <p:cNvSpPr/>
           <p:nvPr>
-            <p:ph idx="100" type="title" hasCustomPrompt="1"/>
-          </p:nvPr>
-        </p:nvSpPr>
-        <p:spPr>
-          <a:xfrm>
-            <a:off x="548640" y="411480"/>
-            <a:ext cx="8046720" cy="868680"/>
+            <p:ph idx="100" type="body" hasCustomPrompt="1"/>
+          </p:nvPr>
+        </p:nvSpPr>
+        <p:spPr>
+          <a:xfrm>
+            <a:off x="548640" y="365760"/>
+            <a:ext cx="8046720" cy="256032"/>
           </a:xfrm>
           <a:prstGeom prst="rect">
             <a:avLst/>
@@ -13413,7 +13841,37 @@
             <a:pPr indent="0" marL="0">
               <a:buNone/>
             </a:pPr>
-            <a:endParaRPr lang="en-US" sz="3000" dirty="0"/>
+            <a:endParaRPr lang="en-US" sz="900" dirty="0"/>
+          </a:p>
+        </p:txBody>
+      </p:sp>
+      <p:sp>
+        <p:nvSpPr>
+          <p:cNvPr id="4" name="Text 0"/>
+          <p:cNvSpPr/>
+          <p:nvPr>
+            <p:ph idx="101" type="title" hasCustomPrompt="1"/>
+          </p:nvPr>
+        </p:nvSpPr>
+        <p:spPr>
+          <a:xfrm>
+            <a:off x="548640" y="621792"/>
+            <a:ext cx="8046720" cy="731520"/>
+          </a:xfrm>
+          <a:prstGeom prst="rect">
+            <a:avLst/>
+          </a:prstGeom>
+          <a:noFill/>
+          <a:ln/>
+        </p:spPr>
+        <p:txBody>
+          <a:bodyPr wrap="square" lIns="0" tIns="0" rIns="0" bIns="0" rtlCol="0" anchor="ctr"/>
+          <a:lstStyle/>
+          <a:p>
+            <a:pPr algn="l" indent="0" marL="0">
+              <a:buNone/>
+            </a:pPr>
+            <a:endParaRPr lang="en-US" sz="2800" dirty="0"/>
           </a:p>
         </p:txBody>
       </p:sp>
@@ -13492,13 +13950,13 @@
           <p:cNvPr id="3" name="Text 0"/>
           <p:cNvSpPr/>
           <p:nvPr>
-            <p:ph idx="100" type="title" hasCustomPrompt="1"/>
-          </p:nvPr>
-        </p:nvSpPr>
-        <p:spPr>
-          <a:xfrm>
-            <a:off x="548640" y="411480"/>
-            <a:ext cx="8046720" cy="868680"/>
+            <p:ph idx="100" type="body" hasCustomPrompt="1"/>
+          </p:nvPr>
+        </p:nvSpPr>
+        <p:spPr>
+          <a:xfrm>
+            <a:off x="548640" y="365760"/>
+            <a:ext cx="8046720" cy="256032"/>
           </a:xfrm>
           <a:prstGeom prst="rect">
             <a:avLst/>
@@ -13513,7 +13971,7 @@
             <a:pPr indent="0" marL="0">
               <a:buNone/>
             </a:pPr>
-            <a:endParaRPr lang="en-US" sz="3000" dirty="0"/>
+            <a:endParaRPr lang="en-US" sz="900" dirty="0"/>
           </a:p>
         </p:txBody>
       </p:sp>
@@ -13522,7 +13980,37 @@
           <p:cNvPr id="4" name="Text 0"/>
           <p:cNvSpPr/>
           <p:nvPr>
-            <p:ph idx="101" type="body" hasCustomPrompt="1"/>
+            <p:ph idx="101" type="title" hasCustomPrompt="1"/>
+          </p:nvPr>
+        </p:nvSpPr>
+        <p:spPr>
+          <a:xfrm>
+            <a:off x="548640" y="621792"/>
+            <a:ext cx="8046720" cy="731520"/>
+          </a:xfrm>
+          <a:prstGeom prst="rect">
+            <a:avLst/>
+          </a:prstGeom>
+          <a:noFill/>
+          <a:ln/>
+        </p:spPr>
+        <p:txBody>
+          <a:bodyPr wrap="square" lIns="0" tIns="0" rIns="0" bIns="0" rtlCol="0" anchor="ctr"/>
+          <a:lstStyle/>
+          <a:p>
+            <a:pPr algn="l" indent="0" marL="0">
+              <a:buNone/>
+            </a:pPr>
+            <a:endParaRPr lang="en-US" sz="2800" dirty="0"/>
+          </a:p>
+        </p:txBody>
+      </p:sp>
+      <p:sp>
+        <p:nvSpPr>
+          <p:cNvPr id="5" name="Text 0"/>
+          <p:cNvSpPr/>
+          <p:nvPr>
+            <p:ph idx="102" type="body" hasCustomPrompt="1"/>
           </p:nvPr>
         </p:nvSpPr>
         <p:spPr>
@@ -13552,10 +14040,10 @@
       </p:sp>
       <p:sp>
         <p:nvSpPr>
-          <p:cNvPr id="5" name="Text 0"/>
+          <p:cNvPr id="6" name="Text 0"/>
           <p:cNvSpPr/>
           <p:nvPr>
-            <p:ph idx="102" type="body" hasCustomPrompt="1"/>
+            <p:ph idx="103" type="body" hasCustomPrompt="1"/>
           </p:nvPr>
         </p:nvSpPr>
         <p:spPr>
@@ -13658,13 +14146,13 @@
           <p:cNvPr id="3" name="Text 0"/>
           <p:cNvSpPr/>
           <p:nvPr>
-            <p:ph idx="100" type="title" hasCustomPrompt="1"/>
-          </p:nvPr>
-        </p:nvSpPr>
-        <p:spPr>
-          <a:xfrm>
-            <a:off x="548640" y="411480"/>
-            <a:ext cx="8046720" cy="868680"/>
+            <p:ph idx="100" type="body" hasCustomPrompt="1"/>
+          </p:nvPr>
+        </p:nvSpPr>
+        <p:spPr>
+          <a:xfrm>
+            <a:off x="548640" y="365760"/>
+            <a:ext cx="8046720" cy="256032"/>
           </a:xfrm>
           <a:prstGeom prst="rect">
             <a:avLst/>
@@ -13679,7 +14167,7 @@
             <a:pPr indent="0" marL="0">
               <a:buNone/>
             </a:pPr>
-            <a:endParaRPr lang="en-US" sz="3000" dirty="0"/>
+            <a:endParaRPr lang="en-US" sz="900" dirty="0"/>
           </a:p>
         </p:txBody>
       </p:sp>
@@ -13688,7 +14176,37 @@
           <p:cNvPr id="4" name="Text 0"/>
           <p:cNvSpPr/>
           <p:nvPr>
-            <p:ph idx="101" hasCustomPrompt="1"/>
+            <p:ph idx="101" type="title" hasCustomPrompt="1"/>
+          </p:nvPr>
+        </p:nvSpPr>
+        <p:spPr>
+          <a:xfrm>
+            <a:off x="548640" y="621792"/>
+            <a:ext cx="8046720" cy="731520"/>
+          </a:xfrm>
+          <a:prstGeom prst="rect">
+            <a:avLst/>
+          </a:prstGeom>
+          <a:noFill/>
+          <a:ln/>
+        </p:spPr>
+        <p:txBody>
+          <a:bodyPr wrap="square" lIns="0" tIns="0" rIns="0" bIns="0" rtlCol="0" anchor="ctr"/>
+          <a:lstStyle/>
+          <a:p>
+            <a:pPr algn="l" indent="0" marL="0">
+              <a:buNone/>
+            </a:pPr>
+            <a:endParaRPr lang="en-US" sz="2800" dirty="0"/>
+          </a:p>
+        </p:txBody>
+      </p:sp>
+      <p:sp>
+        <p:nvSpPr>
+          <p:cNvPr id="5" name="Text 0"/>
+          <p:cNvSpPr/>
+          <p:nvPr>
+            <p:ph idx="102" hasCustomPrompt="1"/>
           </p:nvPr>
         </p:nvSpPr>
         <p:spPr>
@@ -13715,10 +14233,10 @@
       </p:sp>
       <p:sp>
         <p:nvSpPr>
-          <p:cNvPr id="5" name="Text 0"/>
+          <p:cNvPr id="6" name="Text 0"/>
           <p:cNvSpPr/>
           <p:nvPr>
-            <p:ph idx="102" type="body" hasCustomPrompt="1"/>
+            <p:ph idx="103" type="body" hasCustomPrompt="1"/>
           </p:nvPr>
         </p:nvSpPr>
         <p:spPr>
@@ -13948,13 +14466,13 @@
           <p:cNvPr id="3" name="Text 1"/>
           <p:cNvSpPr/>
           <p:nvPr>
-            <p:ph idx="102" type="title" hasCustomPrompt="1"/>
-          </p:nvPr>
-        </p:nvSpPr>
-        <p:spPr>
-          <a:xfrm>
-            <a:off x="548640" y="411480"/>
-            <a:ext cx="8046720" cy="868680"/>
+            <p:ph idx="102" type="body" hasCustomPrompt="1"/>
+          </p:nvPr>
+        </p:nvSpPr>
+        <p:spPr>
+          <a:xfrm>
+            <a:off x="548640" y="365760"/>
+            <a:ext cx="8046720" cy="256032"/>
           </a:xfrm>
           <a:prstGeom prst="rect">
             <a:avLst/>
@@ -13969,7 +14487,7 @@
             <a:pPr indent="0" marL="0">
               <a:buNone/>
             </a:pPr>
-            <a:endParaRPr lang="en-US" sz="3000" dirty="0"/>
+            <a:endParaRPr lang="en-US" sz="900" dirty="0"/>
           </a:p>
         </p:txBody>
       </p:sp>
@@ -13978,7 +14496,37 @@
           <p:cNvPr id="4" name="Text 1"/>
           <p:cNvSpPr/>
           <p:nvPr>
-            <p:ph idx="103" type="body" hasCustomPrompt="1"/>
+            <p:ph idx="103" type="title" hasCustomPrompt="1"/>
+          </p:nvPr>
+        </p:nvSpPr>
+        <p:spPr>
+          <a:xfrm>
+            <a:off x="548640" y="621792"/>
+            <a:ext cx="8046720" cy="731520"/>
+          </a:xfrm>
+          <a:prstGeom prst="rect">
+            <a:avLst/>
+          </a:prstGeom>
+          <a:noFill/>
+          <a:ln/>
+        </p:spPr>
+        <p:txBody>
+          <a:bodyPr wrap="square" lIns="0" tIns="0" rIns="0" bIns="0" rtlCol="0" anchor="ctr"/>
+          <a:lstStyle/>
+          <a:p>
+            <a:pPr algn="l" indent="0" marL="0">
+              <a:buNone/>
+            </a:pPr>
+            <a:endParaRPr lang="en-US" sz="2800" dirty="0"/>
+          </a:p>
+        </p:txBody>
+      </p:sp>
+      <p:sp>
+        <p:nvSpPr>
+          <p:cNvPr id="5" name="Text 1"/>
+          <p:cNvSpPr/>
+          <p:nvPr>
+            <p:ph idx="104" type="body" hasCustomPrompt="1"/>
           </p:nvPr>
         </p:nvSpPr>
         <p:spPr>

</xml_diff>